<commit_message>
Deploy sales_presentation_2b.pptx to 2B Sales OS
</commit_message>
<xml_diff>
--- a/sales_presentation_2b.pptx
+++ b/sales_presentation_2b.pptx
@@ -201,7 +201,7 @@
             </a:lvl1pPr>
           </a:lstStyle>
           <a:p>
-            <a:fld id="{BE390537-281A-4449-AB75-15E19A7CB263}" type="datetimeFigureOut">
+            <a:fld id="{0204756F-B4C2-48FB-947B-034FA4F82B0F}" type="datetimeFigureOut">
               <a:rPr lang="en-US" smtClean="0"/>
               <a:t>10/1/2026</a:t>
             </a:fld>
@@ -359,7 +359,7 @@
             </a:lvl1pPr>
           </a:lstStyle>
           <a:p>
-            <a:fld id="{882ED84D-F6D7-4988-86E3-4A5D8F53EA3D}" type="slidenum">
+            <a:fld id="{BF1E0DE7-A838-44D3-9086-16401B62A323}" type="slidenum">
               <a:rPr lang="en-US" smtClean="0"/>
               <a:t>‹#›</a:t>
             </a:fld>
@@ -370,7 +370,7 @@
     </p:spTree>
     <p:extLst>
       <p:ext uri="{BB962C8B-B14F-4D97-AF65-F5344CB8AC3E}">
-        <p14:creationId xmlns:p14="http://schemas.microsoft.com/office/powerpoint/2010/main" val="2366675082"/>
+        <p14:creationId xmlns:p14="http://schemas.microsoft.com/office/powerpoint/2010/main" val="3461989312"/>
       </p:ext>
     </p:extLst>
   </p:cSld>
@@ -537,7 +537,7 @@
           <a:bodyPr/>
           <a:lstStyle/>
           <a:p>
-            <a:fld id="{882ED84D-F6D7-4988-86E3-4A5D8F53EA3D}" type="slidenum">
+            <a:fld id="{BF1E0DE7-A838-44D3-9086-16401B62A323}" type="slidenum">
               <a:rPr lang="en-US" smtClean="0"/>
               <a:t>1</a:t>
             </a:fld>
@@ -548,7 +548,7 @@
     </p:spTree>
     <p:extLst>
       <p:ext uri="{BB962C8B-B14F-4D97-AF65-F5344CB8AC3E}">
-        <p14:creationId xmlns:p14="http://schemas.microsoft.com/office/powerpoint/2010/main" val="3814745413"/>
+        <p14:creationId xmlns:p14="http://schemas.microsoft.com/office/powerpoint/2010/main" val="511145908"/>
       </p:ext>
     </p:extLst>
   </p:cSld>
@@ -625,7 +625,7 @@
           <a:bodyPr/>
           <a:lstStyle/>
           <a:p>
-            <a:fld id="{882ED84D-F6D7-4988-86E3-4A5D8F53EA3D}" type="slidenum">
+            <a:fld id="{BF1E0DE7-A838-44D3-9086-16401B62A323}" type="slidenum">
               <a:rPr lang="en-US" smtClean="0"/>
               <a:t>10</a:t>
             </a:fld>
@@ -636,7 +636,7 @@
     </p:spTree>
     <p:extLst>
       <p:ext uri="{BB962C8B-B14F-4D97-AF65-F5344CB8AC3E}">
-        <p14:creationId xmlns:p14="http://schemas.microsoft.com/office/powerpoint/2010/main" val="4266521108"/>
+        <p14:creationId xmlns:p14="http://schemas.microsoft.com/office/powerpoint/2010/main" val="3825972907"/>
       </p:ext>
     </p:extLst>
   </p:cSld>
@@ -713,7 +713,7 @@
           <a:bodyPr/>
           <a:lstStyle/>
           <a:p>
-            <a:fld id="{882ED84D-F6D7-4988-86E3-4A5D8F53EA3D}" type="slidenum">
+            <a:fld id="{BF1E0DE7-A838-44D3-9086-16401B62A323}" type="slidenum">
               <a:rPr lang="en-US" smtClean="0"/>
               <a:t>11</a:t>
             </a:fld>
@@ -724,7 +724,7 @@
     </p:spTree>
     <p:extLst>
       <p:ext uri="{BB962C8B-B14F-4D97-AF65-F5344CB8AC3E}">
-        <p14:creationId xmlns:p14="http://schemas.microsoft.com/office/powerpoint/2010/main" val="2113161790"/>
+        <p14:creationId xmlns:p14="http://schemas.microsoft.com/office/powerpoint/2010/main" val="2503370267"/>
       </p:ext>
     </p:extLst>
   </p:cSld>
@@ -804,7 +804,7 @@
           <a:bodyPr/>
           <a:lstStyle/>
           <a:p>
-            <a:fld id="{882ED84D-F6D7-4988-86E3-4A5D8F53EA3D}" type="slidenum">
+            <a:fld id="{BF1E0DE7-A838-44D3-9086-16401B62A323}" type="slidenum">
               <a:rPr lang="en-US" smtClean="0"/>
               <a:t>12</a:t>
             </a:fld>
@@ -815,7 +815,7 @@
     </p:spTree>
     <p:extLst>
       <p:ext uri="{BB962C8B-B14F-4D97-AF65-F5344CB8AC3E}">
-        <p14:creationId xmlns:p14="http://schemas.microsoft.com/office/powerpoint/2010/main" val="941969930"/>
+        <p14:creationId xmlns:p14="http://schemas.microsoft.com/office/powerpoint/2010/main" val="1870320875"/>
       </p:ext>
     </p:extLst>
   </p:cSld>
@@ -892,7 +892,7 @@
           <a:bodyPr/>
           <a:lstStyle/>
           <a:p>
-            <a:fld id="{882ED84D-F6D7-4988-86E3-4A5D8F53EA3D}" type="slidenum">
+            <a:fld id="{BF1E0DE7-A838-44D3-9086-16401B62A323}" type="slidenum">
               <a:rPr lang="en-US" smtClean="0"/>
               <a:t>2</a:t>
             </a:fld>
@@ -903,7 +903,7 @@
     </p:spTree>
     <p:extLst>
       <p:ext uri="{BB962C8B-B14F-4D97-AF65-F5344CB8AC3E}">
-        <p14:creationId xmlns:p14="http://schemas.microsoft.com/office/powerpoint/2010/main" val="2045662393"/>
+        <p14:creationId xmlns:p14="http://schemas.microsoft.com/office/powerpoint/2010/main" val="1085832156"/>
       </p:ext>
     </p:extLst>
   </p:cSld>
@@ -980,7 +980,7 @@
           <a:bodyPr/>
           <a:lstStyle/>
           <a:p>
-            <a:fld id="{882ED84D-F6D7-4988-86E3-4A5D8F53EA3D}" type="slidenum">
+            <a:fld id="{BF1E0DE7-A838-44D3-9086-16401B62A323}" type="slidenum">
               <a:rPr lang="en-US" smtClean="0"/>
               <a:t>3</a:t>
             </a:fld>
@@ -991,7 +991,7 @@
     </p:spTree>
     <p:extLst>
       <p:ext uri="{BB962C8B-B14F-4D97-AF65-F5344CB8AC3E}">
-        <p14:creationId xmlns:p14="http://schemas.microsoft.com/office/powerpoint/2010/main" val="1095457342"/>
+        <p14:creationId xmlns:p14="http://schemas.microsoft.com/office/powerpoint/2010/main" val="2024237824"/>
       </p:ext>
     </p:extLst>
   </p:cSld>
@@ -1068,7 +1068,7 @@
           <a:bodyPr/>
           <a:lstStyle/>
           <a:p>
-            <a:fld id="{882ED84D-F6D7-4988-86E3-4A5D8F53EA3D}" type="slidenum">
+            <a:fld id="{BF1E0DE7-A838-44D3-9086-16401B62A323}" type="slidenum">
               <a:rPr lang="en-US" smtClean="0"/>
               <a:t>4</a:t>
             </a:fld>
@@ -1079,7 +1079,7 @@
     </p:spTree>
     <p:extLst>
       <p:ext uri="{BB962C8B-B14F-4D97-AF65-F5344CB8AC3E}">
-        <p14:creationId xmlns:p14="http://schemas.microsoft.com/office/powerpoint/2010/main" val="140754063"/>
+        <p14:creationId xmlns:p14="http://schemas.microsoft.com/office/powerpoint/2010/main" val="3579890531"/>
       </p:ext>
     </p:extLst>
   </p:cSld>
@@ -1156,7 +1156,7 @@
           <a:bodyPr/>
           <a:lstStyle/>
           <a:p>
-            <a:fld id="{882ED84D-F6D7-4988-86E3-4A5D8F53EA3D}" type="slidenum">
+            <a:fld id="{BF1E0DE7-A838-44D3-9086-16401B62A323}" type="slidenum">
               <a:rPr lang="en-US" smtClean="0"/>
               <a:t>5</a:t>
             </a:fld>
@@ -1167,7 +1167,7 @@
     </p:spTree>
     <p:extLst>
       <p:ext uri="{BB962C8B-B14F-4D97-AF65-F5344CB8AC3E}">
-        <p14:creationId xmlns:p14="http://schemas.microsoft.com/office/powerpoint/2010/main" val="3671877906"/>
+        <p14:creationId xmlns:p14="http://schemas.microsoft.com/office/powerpoint/2010/main" val="1224728650"/>
       </p:ext>
     </p:extLst>
   </p:cSld>
@@ -1244,7 +1244,7 @@
           <a:bodyPr/>
           <a:lstStyle/>
           <a:p>
-            <a:fld id="{882ED84D-F6D7-4988-86E3-4A5D8F53EA3D}" type="slidenum">
+            <a:fld id="{BF1E0DE7-A838-44D3-9086-16401B62A323}" type="slidenum">
               <a:rPr lang="en-US" smtClean="0"/>
               <a:t>6</a:t>
             </a:fld>
@@ -1255,7 +1255,7 @@
     </p:spTree>
     <p:extLst>
       <p:ext uri="{BB962C8B-B14F-4D97-AF65-F5344CB8AC3E}">
-        <p14:creationId xmlns:p14="http://schemas.microsoft.com/office/powerpoint/2010/main" val="169718200"/>
+        <p14:creationId xmlns:p14="http://schemas.microsoft.com/office/powerpoint/2010/main" val="3434409075"/>
       </p:ext>
     </p:extLst>
   </p:cSld>
@@ -1332,7 +1332,7 @@
           <a:bodyPr/>
           <a:lstStyle/>
           <a:p>
-            <a:fld id="{882ED84D-F6D7-4988-86E3-4A5D8F53EA3D}" type="slidenum">
+            <a:fld id="{BF1E0DE7-A838-44D3-9086-16401B62A323}" type="slidenum">
               <a:rPr lang="en-US" smtClean="0"/>
               <a:t>7</a:t>
             </a:fld>
@@ -1343,7 +1343,7 @@
     </p:spTree>
     <p:extLst>
       <p:ext uri="{BB962C8B-B14F-4D97-AF65-F5344CB8AC3E}">
-        <p14:creationId xmlns:p14="http://schemas.microsoft.com/office/powerpoint/2010/main" val="2791607362"/>
+        <p14:creationId xmlns:p14="http://schemas.microsoft.com/office/powerpoint/2010/main" val="3142671044"/>
       </p:ext>
     </p:extLst>
   </p:cSld>
@@ -1420,7 +1420,7 @@
           <a:bodyPr/>
           <a:lstStyle/>
           <a:p>
-            <a:fld id="{882ED84D-F6D7-4988-86E3-4A5D8F53EA3D}" type="slidenum">
+            <a:fld id="{BF1E0DE7-A838-44D3-9086-16401B62A323}" type="slidenum">
               <a:rPr lang="en-US" smtClean="0"/>
               <a:t>8</a:t>
             </a:fld>
@@ -1431,7 +1431,7 @@
     </p:spTree>
     <p:extLst>
       <p:ext uri="{BB962C8B-B14F-4D97-AF65-F5344CB8AC3E}">
-        <p14:creationId xmlns:p14="http://schemas.microsoft.com/office/powerpoint/2010/main" val="910352844"/>
+        <p14:creationId xmlns:p14="http://schemas.microsoft.com/office/powerpoint/2010/main" val="1701548821"/>
       </p:ext>
     </p:extLst>
   </p:cSld>
@@ -1508,7 +1508,7 @@
           <a:bodyPr/>
           <a:lstStyle/>
           <a:p>
-            <a:fld id="{882ED84D-F6D7-4988-86E3-4A5D8F53EA3D}" type="slidenum">
+            <a:fld id="{BF1E0DE7-A838-44D3-9086-16401B62A323}" type="slidenum">
               <a:rPr lang="en-US" smtClean="0"/>
               <a:t>9</a:t>
             </a:fld>
@@ -1519,7 +1519,7 @@
     </p:spTree>
     <p:extLst>
       <p:ext uri="{BB962C8B-B14F-4D97-AF65-F5344CB8AC3E}">
-        <p14:creationId xmlns:p14="http://schemas.microsoft.com/office/powerpoint/2010/main" val="3288857904"/>
+        <p14:creationId xmlns:p14="http://schemas.microsoft.com/office/powerpoint/2010/main" val="2995017024"/>
       </p:ext>
     </p:extLst>
   </p:cSld>
@@ -1551,7 +1551,7 @@
           <p:cNvPr id="2" name="Title 1">
             <a:extLst>
               <a:ext uri="{FF2B5EF4-FFF2-40B4-BE49-F238E27FC236}">
-                <a16:creationId xmlns:a16="http://schemas.microsoft.com/office/drawing/2014/main" id="{E5E9CC3A-80FC-2846-F265-FA33C2FA8AEC}"/>
+                <a16:creationId xmlns:a16="http://schemas.microsoft.com/office/drawing/2014/main" id="{E048BE11-5333-6A28-AD91-C8716EE15C8A}"/>
               </a:ext>
             </a:extLst>
           </p:cNvPr>
@@ -1588,7 +1588,7 @@
           <p:cNvPr id="3" name="Subtitle 2">
             <a:extLst>
               <a:ext uri="{FF2B5EF4-FFF2-40B4-BE49-F238E27FC236}">
-                <a16:creationId xmlns:a16="http://schemas.microsoft.com/office/drawing/2014/main" id="{78936765-1B17-441B-6053-5D8BB992CF28}"/>
+                <a16:creationId xmlns:a16="http://schemas.microsoft.com/office/drawing/2014/main" id="{31E151F4-DFA8-B476-B835-3C39235EBB3D}"/>
               </a:ext>
             </a:extLst>
           </p:cNvPr>
@@ -1658,7 +1658,7 @@
           <p:cNvPr id="4" name="Date Placeholder 3">
             <a:extLst>
               <a:ext uri="{FF2B5EF4-FFF2-40B4-BE49-F238E27FC236}">
-                <a16:creationId xmlns:a16="http://schemas.microsoft.com/office/drawing/2014/main" id="{482AD142-1CE1-961E-93EF-B91AE47E77F5}"/>
+                <a16:creationId xmlns:a16="http://schemas.microsoft.com/office/drawing/2014/main" id="{6114ADA1-B023-E7CB-0CAC-A8AFB39A63C3}"/>
               </a:ext>
             </a:extLst>
           </p:cNvPr>
@@ -1674,7 +1674,7 @@
           <a:bodyPr/>
           <a:lstStyle/>
           <a:p>
-            <a:fld id="{395A4AE7-3451-4A8F-875B-C3782B0A52A7}" type="datetimeFigureOut">
+            <a:fld id="{40FDD52B-EF56-4BB9-AE32-CBE6B0F3120F}" type="datetimeFigureOut">
               <a:rPr lang="en-US" smtClean="0"/>
               <a:t>10/1/2026</a:t>
             </a:fld>
@@ -1687,7 +1687,7 @@
           <p:cNvPr id="5" name="Footer Placeholder 4">
             <a:extLst>
               <a:ext uri="{FF2B5EF4-FFF2-40B4-BE49-F238E27FC236}">
-                <a16:creationId xmlns:a16="http://schemas.microsoft.com/office/drawing/2014/main" id="{1C9AFB0F-298A-1871-4919-78EAE4670702}"/>
+                <a16:creationId xmlns:a16="http://schemas.microsoft.com/office/drawing/2014/main" id="{9A6A72B8-7117-9FB3-FAD0-C45155AF9564}"/>
               </a:ext>
             </a:extLst>
           </p:cNvPr>
@@ -1712,7 +1712,7 @@
           <p:cNvPr id="6" name="Slide Number Placeholder 5">
             <a:extLst>
               <a:ext uri="{FF2B5EF4-FFF2-40B4-BE49-F238E27FC236}">
-                <a16:creationId xmlns:a16="http://schemas.microsoft.com/office/drawing/2014/main" id="{0581898A-5DCE-BB4B-2A2C-E1A7C918D9FD}"/>
+                <a16:creationId xmlns:a16="http://schemas.microsoft.com/office/drawing/2014/main" id="{3F021203-5591-90A6-2C67-266B5CAC03FA}"/>
               </a:ext>
             </a:extLst>
           </p:cNvPr>
@@ -1728,7 +1728,7 @@
           <a:bodyPr/>
           <a:lstStyle/>
           <a:p>
-            <a:fld id="{F4536191-D2F0-4211-9D2E-0A00F1F7E313}" type="slidenum">
+            <a:fld id="{071C626E-CE99-4A38-B122-F832429FE450}" type="slidenum">
               <a:rPr lang="en-US" smtClean="0"/>
               <a:t>‹#›</a:t>
             </a:fld>
@@ -1739,7 +1739,7 @@
     </p:spTree>
     <p:extLst>
       <p:ext uri="{BB962C8B-B14F-4D97-AF65-F5344CB8AC3E}">
-        <p14:creationId xmlns:p14="http://schemas.microsoft.com/office/powerpoint/2010/main" val="3449688069"/>
+        <p14:creationId xmlns:p14="http://schemas.microsoft.com/office/powerpoint/2010/main" val="2095824046"/>
       </p:ext>
     </p:extLst>
   </p:cSld>
@@ -1771,7 +1771,7 @@
           <p:cNvPr id="2" name="Title 1">
             <a:extLst>
               <a:ext uri="{FF2B5EF4-FFF2-40B4-BE49-F238E27FC236}">
-                <a16:creationId xmlns:a16="http://schemas.microsoft.com/office/drawing/2014/main" id="{B5118FC6-34C1-AE86-8E91-B90B2B6E20B2}"/>
+                <a16:creationId xmlns:a16="http://schemas.microsoft.com/office/drawing/2014/main" id="{7EE8B0E1-6FB4-BE9D-2C1D-7807F9741451}"/>
               </a:ext>
             </a:extLst>
           </p:cNvPr>
@@ -1799,7 +1799,7 @@
           <p:cNvPr id="3" name="Vertical Text Placeholder 2">
             <a:extLst>
               <a:ext uri="{FF2B5EF4-FFF2-40B4-BE49-F238E27FC236}">
-                <a16:creationId xmlns:a16="http://schemas.microsoft.com/office/drawing/2014/main" id="{3DF608B1-0458-8DB4-030F-8C18A4C114AB}"/>
+                <a16:creationId xmlns:a16="http://schemas.microsoft.com/office/drawing/2014/main" id="{0B5F4F66-B9F9-6432-2B66-509F9AB2BA14}"/>
               </a:ext>
             </a:extLst>
           </p:cNvPr>
@@ -1856,7 +1856,7 @@
           <p:cNvPr id="4" name="Date Placeholder 3">
             <a:extLst>
               <a:ext uri="{FF2B5EF4-FFF2-40B4-BE49-F238E27FC236}">
-                <a16:creationId xmlns:a16="http://schemas.microsoft.com/office/drawing/2014/main" id="{7C32D167-80B2-C738-4A43-D19DDABBF1D4}"/>
+                <a16:creationId xmlns:a16="http://schemas.microsoft.com/office/drawing/2014/main" id="{D11CCF44-6470-4E74-FF7E-969D76E434C3}"/>
               </a:ext>
             </a:extLst>
           </p:cNvPr>
@@ -1872,7 +1872,7 @@
           <a:bodyPr/>
           <a:lstStyle/>
           <a:p>
-            <a:fld id="{395A4AE7-3451-4A8F-875B-C3782B0A52A7}" type="datetimeFigureOut">
+            <a:fld id="{40FDD52B-EF56-4BB9-AE32-CBE6B0F3120F}" type="datetimeFigureOut">
               <a:rPr lang="en-US" smtClean="0"/>
               <a:t>10/1/2026</a:t>
             </a:fld>
@@ -1885,7 +1885,7 @@
           <p:cNvPr id="5" name="Footer Placeholder 4">
             <a:extLst>
               <a:ext uri="{FF2B5EF4-FFF2-40B4-BE49-F238E27FC236}">
-                <a16:creationId xmlns:a16="http://schemas.microsoft.com/office/drawing/2014/main" id="{B19DD895-66B3-784B-BE63-C983867C4B30}"/>
+                <a16:creationId xmlns:a16="http://schemas.microsoft.com/office/drawing/2014/main" id="{7C1CB355-B6E9-1AC3-B33D-B44DAF87D812}"/>
               </a:ext>
             </a:extLst>
           </p:cNvPr>
@@ -1910,7 +1910,7 @@
           <p:cNvPr id="6" name="Slide Number Placeholder 5">
             <a:extLst>
               <a:ext uri="{FF2B5EF4-FFF2-40B4-BE49-F238E27FC236}">
-                <a16:creationId xmlns:a16="http://schemas.microsoft.com/office/drawing/2014/main" id="{C8CA480B-4056-F7A1-0E23-C8511C58D5BD}"/>
+                <a16:creationId xmlns:a16="http://schemas.microsoft.com/office/drawing/2014/main" id="{1A98C8B7-E311-E405-51D6-8498EE758AA4}"/>
               </a:ext>
             </a:extLst>
           </p:cNvPr>
@@ -1926,7 +1926,7 @@
           <a:bodyPr/>
           <a:lstStyle/>
           <a:p>
-            <a:fld id="{F4536191-D2F0-4211-9D2E-0A00F1F7E313}" type="slidenum">
+            <a:fld id="{071C626E-CE99-4A38-B122-F832429FE450}" type="slidenum">
               <a:rPr lang="en-US" smtClean="0"/>
               <a:t>‹#›</a:t>
             </a:fld>
@@ -1937,7 +1937,7 @@
     </p:spTree>
     <p:extLst>
       <p:ext uri="{BB962C8B-B14F-4D97-AF65-F5344CB8AC3E}">
-        <p14:creationId xmlns:p14="http://schemas.microsoft.com/office/powerpoint/2010/main" val="2823649878"/>
+        <p14:creationId xmlns:p14="http://schemas.microsoft.com/office/powerpoint/2010/main" val="3899036658"/>
       </p:ext>
     </p:extLst>
   </p:cSld>
@@ -1969,7 +1969,7 @@
           <p:cNvPr id="2" name="Vertical Title 1">
             <a:extLst>
               <a:ext uri="{FF2B5EF4-FFF2-40B4-BE49-F238E27FC236}">
-                <a16:creationId xmlns:a16="http://schemas.microsoft.com/office/drawing/2014/main" id="{8663FD30-3846-5507-80F5-86624DE3430B}"/>
+                <a16:creationId xmlns:a16="http://schemas.microsoft.com/office/drawing/2014/main" id="{F7CB5595-407E-C79B-BBF0-E7E881B6E51E}"/>
               </a:ext>
             </a:extLst>
           </p:cNvPr>
@@ -2002,7 +2002,7 @@
           <p:cNvPr id="3" name="Vertical Text Placeholder 2">
             <a:extLst>
               <a:ext uri="{FF2B5EF4-FFF2-40B4-BE49-F238E27FC236}">
-                <a16:creationId xmlns:a16="http://schemas.microsoft.com/office/drawing/2014/main" id="{9BB5840E-8903-8770-E263-62A47F5611F7}"/>
+                <a16:creationId xmlns:a16="http://schemas.microsoft.com/office/drawing/2014/main" id="{81031424-3A85-B43E-B674-3137F2DF52B1}"/>
               </a:ext>
             </a:extLst>
           </p:cNvPr>
@@ -2064,7 +2064,7 @@
           <p:cNvPr id="4" name="Date Placeholder 3">
             <a:extLst>
               <a:ext uri="{FF2B5EF4-FFF2-40B4-BE49-F238E27FC236}">
-                <a16:creationId xmlns:a16="http://schemas.microsoft.com/office/drawing/2014/main" id="{F8E541B3-8219-C3C8-8F7A-38717035211B}"/>
+                <a16:creationId xmlns:a16="http://schemas.microsoft.com/office/drawing/2014/main" id="{8F6CC118-0149-B59D-3B5E-A6ED87EA80D0}"/>
               </a:ext>
             </a:extLst>
           </p:cNvPr>
@@ -2080,7 +2080,7 @@
           <a:bodyPr/>
           <a:lstStyle/>
           <a:p>
-            <a:fld id="{395A4AE7-3451-4A8F-875B-C3782B0A52A7}" type="datetimeFigureOut">
+            <a:fld id="{40FDD52B-EF56-4BB9-AE32-CBE6B0F3120F}" type="datetimeFigureOut">
               <a:rPr lang="en-US" smtClean="0"/>
               <a:t>10/1/2026</a:t>
             </a:fld>
@@ -2093,7 +2093,7 @@
           <p:cNvPr id="5" name="Footer Placeholder 4">
             <a:extLst>
               <a:ext uri="{FF2B5EF4-FFF2-40B4-BE49-F238E27FC236}">
-                <a16:creationId xmlns:a16="http://schemas.microsoft.com/office/drawing/2014/main" id="{1753FD38-A82E-CAB5-B659-98A6CF5997F5}"/>
+                <a16:creationId xmlns:a16="http://schemas.microsoft.com/office/drawing/2014/main" id="{FD405318-EC81-FF28-9948-AAEB4D1391BB}"/>
               </a:ext>
             </a:extLst>
           </p:cNvPr>
@@ -2118,7 +2118,7 @@
           <p:cNvPr id="6" name="Slide Number Placeholder 5">
             <a:extLst>
               <a:ext uri="{FF2B5EF4-FFF2-40B4-BE49-F238E27FC236}">
-                <a16:creationId xmlns:a16="http://schemas.microsoft.com/office/drawing/2014/main" id="{F8DE3E2B-2E56-5A9F-8873-5BB08DA017CA}"/>
+                <a16:creationId xmlns:a16="http://schemas.microsoft.com/office/drawing/2014/main" id="{09A2A13E-1506-DD19-4AC3-7AF16FF2ADDE}"/>
               </a:ext>
             </a:extLst>
           </p:cNvPr>
@@ -2134,7 +2134,7 @@
           <a:bodyPr/>
           <a:lstStyle/>
           <a:p>
-            <a:fld id="{F4536191-D2F0-4211-9D2E-0A00F1F7E313}" type="slidenum">
+            <a:fld id="{071C626E-CE99-4A38-B122-F832429FE450}" type="slidenum">
               <a:rPr lang="en-US" smtClean="0"/>
               <a:t>‹#›</a:t>
             </a:fld>
@@ -2145,7 +2145,7 @@
     </p:spTree>
     <p:extLst>
       <p:ext uri="{BB962C8B-B14F-4D97-AF65-F5344CB8AC3E}">
-        <p14:creationId xmlns:p14="http://schemas.microsoft.com/office/powerpoint/2010/main" val="1221317867"/>
+        <p14:creationId xmlns:p14="http://schemas.microsoft.com/office/powerpoint/2010/main" val="2407644640"/>
       </p:ext>
     </p:extLst>
   </p:cSld>
@@ -2177,7 +2177,7 @@
           <p:cNvPr id="2" name="Title 1">
             <a:extLst>
               <a:ext uri="{FF2B5EF4-FFF2-40B4-BE49-F238E27FC236}">
-                <a16:creationId xmlns:a16="http://schemas.microsoft.com/office/drawing/2014/main" id="{188C4D42-BE58-7748-A9E4-5C491328C3DB}"/>
+                <a16:creationId xmlns:a16="http://schemas.microsoft.com/office/drawing/2014/main" id="{58CEBBD8-FE28-C24F-CFC4-5D66D9E031B2}"/>
               </a:ext>
             </a:extLst>
           </p:cNvPr>
@@ -2205,7 +2205,7 @@
           <p:cNvPr id="3" name="Content Placeholder 2">
             <a:extLst>
               <a:ext uri="{FF2B5EF4-FFF2-40B4-BE49-F238E27FC236}">
-                <a16:creationId xmlns:a16="http://schemas.microsoft.com/office/drawing/2014/main" id="{AD2CF431-BD2C-AC4E-7053-033DBD6C1117}"/>
+                <a16:creationId xmlns:a16="http://schemas.microsoft.com/office/drawing/2014/main" id="{8E0389D2-7F18-B6F1-6352-7995FB4EB58F}"/>
               </a:ext>
             </a:extLst>
           </p:cNvPr>
@@ -2262,7 +2262,7 @@
           <p:cNvPr id="4" name="Date Placeholder 3">
             <a:extLst>
               <a:ext uri="{FF2B5EF4-FFF2-40B4-BE49-F238E27FC236}">
-                <a16:creationId xmlns:a16="http://schemas.microsoft.com/office/drawing/2014/main" id="{1567B699-C047-BCD4-3494-B79632623AA0}"/>
+                <a16:creationId xmlns:a16="http://schemas.microsoft.com/office/drawing/2014/main" id="{F577E4F6-28B5-BED7-3B05-1726CF353E1F}"/>
               </a:ext>
             </a:extLst>
           </p:cNvPr>
@@ -2278,7 +2278,7 @@
           <a:bodyPr/>
           <a:lstStyle/>
           <a:p>
-            <a:fld id="{395A4AE7-3451-4A8F-875B-C3782B0A52A7}" type="datetimeFigureOut">
+            <a:fld id="{40FDD52B-EF56-4BB9-AE32-CBE6B0F3120F}" type="datetimeFigureOut">
               <a:rPr lang="en-US" smtClean="0"/>
               <a:t>10/1/2026</a:t>
             </a:fld>
@@ -2291,7 +2291,7 @@
           <p:cNvPr id="5" name="Footer Placeholder 4">
             <a:extLst>
               <a:ext uri="{FF2B5EF4-FFF2-40B4-BE49-F238E27FC236}">
-                <a16:creationId xmlns:a16="http://schemas.microsoft.com/office/drawing/2014/main" id="{B0E4A260-86BE-BD4D-B2B7-633C49206832}"/>
+                <a16:creationId xmlns:a16="http://schemas.microsoft.com/office/drawing/2014/main" id="{606EABF6-97DA-E26B-0D48-A22E0F1B2A54}"/>
               </a:ext>
             </a:extLst>
           </p:cNvPr>
@@ -2316,7 +2316,7 @@
           <p:cNvPr id="6" name="Slide Number Placeholder 5">
             <a:extLst>
               <a:ext uri="{FF2B5EF4-FFF2-40B4-BE49-F238E27FC236}">
-                <a16:creationId xmlns:a16="http://schemas.microsoft.com/office/drawing/2014/main" id="{C760B33F-773E-25AD-4F08-124C4A8BEEBE}"/>
+                <a16:creationId xmlns:a16="http://schemas.microsoft.com/office/drawing/2014/main" id="{7F83059E-478F-035F-465D-FAAB920EA95E}"/>
               </a:ext>
             </a:extLst>
           </p:cNvPr>
@@ -2332,7 +2332,7 @@
           <a:bodyPr/>
           <a:lstStyle/>
           <a:p>
-            <a:fld id="{F4536191-D2F0-4211-9D2E-0A00F1F7E313}" type="slidenum">
+            <a:fld id="{071C626E-CE99-4A38-B122-F832429FE450}" type="slidenum">
               <a:rPr lang="en-US" smtClean="0"/>
               <a:t>‹#›</a:t>
             </a:fld>
@@ -2343,7 +2343,7 @@
     </p:spTree>
     <p:extLst>
       <p:ext uri="{BB962C8B-B14F-4D97-AF65-F5344CB8AC3E}">
-        <p14:creationId xmlns:p14="http://schemas.microsoft.com/office/powerpoint/2010/main" val="3086457270"/>
+        <p14:creationId xmlns:p14="http://schemas.microsoft.com/office/powerpoint/2010/main" val="1845346816"/>
       </p:ext>
     </p:extLst>
   </p:cSld>
@@ -2375,7 +2375,7 @@
           <p:cNvPr id="2" name="Title 1">
             <a:extLst>
               <a:ext uri="{FF2B5EF4-FFF2-40B4-BE49-F238E27FC236}">
-                <a16:creationId xmlns:a16="http://schemas.microsoft.com/office/drawing/2014/main" id="{AF4887A6-2B2F-0B13-3D4A-1F337C2F615C}"/>
+                <a16:creationId xmlns:a16="http://schemas.microsoft.com/office/drawing/2014/main" id="{F2CDF2C2-79D2-FFFD-57D8-297C47EC7970}"/>
               </a:ext>
             </a:extLst>
           </p:cNvPr>
@@ -2412,7 +2412,7 @@
           <p:cNvPr id="3" name="Text Placeholder 2">
             <a:extLst>
               <a:ext uri="{FF2B5EF4-FFF2-40B4-BE49-F238E27FC236}">
-                <a16:creationId xmlns:a16="http://schemas.microsoft.com/office/drawing/2014/main" id="{D3DC5AD8-8755-04E1-097B-E8613790AA50}"/>
+                <a16:creationId xmlns:a16="http://schemas.microsoft.com/office/drawing/2014/main" id="{0304D6C0-72F6-6CAC-2D91-61E5625E6AA9}"/>
               </a:ext>
             </a:extLst>
           </p:cNvPr>
@@ -2537,7 +2537,7 @@
           <p:cNvPr id="4" name="Date Placeholder 3">
             <a:extLst>
               <a:ext uri="{FF2B5EF4-FFF2-40B4-BE49-F238E27FC236}">
-                <a16:creationId xmlns:a16="http://schemas.microsoft.com/office/drawing/2014/main" id="{AD0736CC-636C-33D2-1AB7-CD85B2225A45}"/>
+                <a16:creationId xmlns:a16="http://schemas.microsoft.com/office/drawing/2014/main" id="{579F7243-B3CE-B514-8F36-E27421F758B7}"/>
               </a:ext>
             </a:extLst>
           </p:cNvPr>
@@ -2553,7 +2553,7 @@
           <a:bodyPr/>
           <a:lstStyle/>
           <a:p>
-            <a:fld id="{395A4AE7-3451-4A8F-875B-C3782B0A52A7}" type="datetimeFigureOut">
+            <a:fld id="{40FDD52B-EF56-4BB9-AE32-CBE6B0F3120F}" type="datetimeFigureOut">
               <a:rPr lang="en-US" smtClean="0"/>
               <a:t>10/1/2026</a:t>
             </a:fld>
@@ -2566,7 +2566,7 @@
           <p:cNvPr id="5" name="Footer Placeholder 4">
             <a:extLst>
               <a:ext uri="{FF2B5EF4-FFF2-40B4-BE49-F238E27FC236}">
-                <a16:creationId xmlns:a16="http://schemas.microsoft.com/office/drawing/2014/main" id="{FD667713-51BF-0CC8-D8E8-87EC421D900C}"/>
+                <a16:creationId xmlns:a16="http://schemas.microsoft.com/office/drawing/2014/main" id="{9BBCA5F1-1831-676B-E979-943CE4E40134}"/>
               </a:ext>
             </a:extLst>
           </p:cNvPr>
@@ -2591,7 +2591,7 @@
           <p:cNvPr id="6" name="Slide Number Placeholder 5">
             <a:extLst>
               <a:ext uri="{FF2B5EF4-FFF2-40B4-BE49-F238E27FC236}">
-                <a16:creationId xmlns:a16="http://schemas.microsoft.com/office/drawing/2014/main" id="{789963D3-EE64-9037-1F34-AEC3C52AE62A}"/>
+                <a16:creationId xmlns:a16="http://schemas.microsoft.com/office/drawing/2014/main" id="{F6980157-505F-69ED-ACFB-A3BBA45BB8DB}"/>
               </a:ext>
             </a:extLst>
           </p:cNvPr>
@@ -2607,7 +2607,7 @@
           <a:bodyPr/>
           <a:lstStyle/>
           <a:p>
-            <a:fld id="{F4536191-D2F0-4211-9D2E-0A00F1F7E313}" type="slidenum">
+            <a:fld id="{071C626E-CE99-4A38-B122-F832429FE450}" type="slidenum">
               <a:rPr lang="en-US" smtClean="0"/>
               <a:t>‹#›</a:t>
             </a:fld>
@@ -2618,7 +2618,7 @@
     </p:spTree>
     <p:extLst>
       <p:ext uri="{BB962C8B-B14F-4D97-AF65-F5344CB8AC3E}">
-        <p14:creationId xmlns:p14="http://schemas.microsoft.com/office/powerpoint/2010/main" val="3437477543"/>
+        <p14:creationId xmlns:p14="http://schemas.microsoft.com/office/powerpoint/2010/main" val="126104556"/>
       </p:ext>
     </p:extLst>
   </p:cSld>
@@ -2650,7 +2650,7 @@
           <p:cNvPr id="2" name="Title 1">
             <a:extLst>
               <a:ext uri="{FF2B5EF4-FFF2-40B4-BE49-F238E27FC236}">
-                <a16:creationId xmlns:a16="http://schemas.microsoft.com/office/drawing/2014/main" id="{90786682-9D54-F46E-8AE3-D64AEC2F3FDB}"/>
+                <a16:creationId xmlns:a16="http://schemas.microsoft.com/office/drawing/2014/main" id="{F34D10F8-5D47-8837-8171-CEB65098D2C1}"/>
               </a:ext>
             </a:extLst>
           </p:cNvPr>
@@ -2678,7 +2678,7 @@
           <p:cNvPr id="3" name="Content Placeholder 2">
             <a:extLst>
               <a:ext uri="{FF2B5EF4-FFF2-40B4-BE49-F238E27FC236}">
-                <a16:creationId xmlns:a16="http://schemas.microsoft.com/office/drawing/2014/main" id="{1B0682EC-5196-1344-7710-00ACAC48DD0C}"/>
+                <a16:creationId xmlns:a16="http://schemas.microsoft.com/office/drawing/2014/main" id="{10C51958-C840-6212-2B40-74240F7D69AD}"/>
               </a:ext>
             </a:extLst>
           </p:cNvPr>
@@ -2740,7 +2740,7 @@
           <p:cNvPr id="4" name="Content Placeholder 3">
             <a:extLst>
               <a:ext uri="{FF2B5EF4-FFF2-40B4-BE49-F238E27FC236}">
-                <a16:creationId xmlns:a16="http://schemas.microsoft.com/office/drawing/2014/main" id="{B777980E-D1DF-EC54-63CC-8E192DA6D72D}"/>
+                <a16:creationId xmlns:a16="http://schemas.microsoft.com/office/drawing/2014/main" id="{6C8CDFC7-DBE5-DC4D-C71C-624F69FB38D2}"/>
               </a:ext>
             </a:extLst>
           </p:cNvPr>
@@ -2802,7 +2802,7 @@
           <p:cNvPr id="5" name="Date Placeholder 4">
             <a:extLst>
               <a:ext uri="{FF2B5EF4-FFF2-40B4-BE49-F238E27FC236}">
-                <a16:creationId xmlns:a16="http://schemas.microsoft.com/office/drawing/2014/main" id="{70AC6391-ABEC-7680-E37F-AAE2447A754C}"/>
+                <a16:creationId xmlns:a16="http://schemas.microsoft.com/office/drawing/2014/main" id="{C318780F-6557-1903-ED3D-A2FB66E1B4E1}"/>
               </a:ext>
             </a:extLst>
           </p:cNvPr>
@@ -2818,7 +2818,7 @@
           <a:bodyPr/>
           <a:lstStyle/>
           <a:p>
-            <a:fld id="{395A4AE7-3451-4A8F-875B-C3782B0A52A7}" type="datetimeFigureOut">
+            <a:fld id="{40FDD52B-EF56-4BB9-AE32-CBE6B0F3120F}" type="datetimeFigureOut">
               <a:rPr lang="en-US" smtClean="0"/>
               <a:t>10/1/2026</a:t>
             </a:fld>
@@ -2831,7 +2831,7 @@
           <p:cNvPr id="6" name="Footer Placeholder 5">
             <a:extLst>
               <a:ext uri="{FF2B5EF4-FFF2-40B4-BE49-F238E27FC236}">
-                <a16:creationId xmlns:a16="http://schemas.microsoft.com/office/drawing/2014/main" id="{533FF904-6FB8-9872-011B-5BAEFDC94330}"/>
+                <a16:creationId xmlns:a16="http://schemas.microsoft.com/office/drawing/2014/main" id="{A67F5FF6-99C0-804C-7520-654129E3F31E}"/>
               </a:ext>
             </a:extLst>
           </p:cNvPr>
@@ -2856,7 +2856,7 @@
           <p:cNvPr id="7" name="Slide Number Placeholder 6">
             <a:extLst>
               <a:ext uri="{FF2B5EF4-FFF2-40B4-BE49-F238E27FC236}">
-                <a16:creationId xmlns:a16="http://schemas.microsoft.com/office/drawing/2014/main" id="{5C232558-1642-552B-7D6E-DFBF7E69CA57}"/>
+                <a16:creationId xmlns:a16="http://schemas.microsoft.com/office/drawing/2014/main" id="{173007C6-4F13-52E3-7A8A-C1CF736E2733}"/>
               </a:ext>
             </a:extLst>
           </p:cNvPr>
@@ -2872,7 +2872,7 @@
           <a:bodyPr/>
           <a:lstStyle/>
           <a:p>
-            <a:fld id="{F4536191-D2F0-4211-9D2E-0A00F1F7E313}" type="slidenum">
+            <a:fld id="{071C626E-CE99-4A38-B122-F832429FE450}" type="slidenum">
               <a:rPr lang="en-US" smtClean="0"/>
               <a:t>‹#›</a:t>
             </a:fld>
@@ -2883,7 +2883,7 @@
     </p:spTree>
     <p:extLst>
       <p:ext uri="{BB962C8B-B14F-4D97-AF65-F5344CB8AC3E}">
-        <p14:creationId xmlns:p14="http://schemas.microsoft.com/office/powerpoint/2010/main" val="3938588509"/>
+        <p14:creationId xmlns:p14="http://schemas.microsoft.com/office/powerpoint/2010/main" val="1578383029"/>
       </p:ext>
     </p:extLst>
   </p:cSld>
@@ -2915,7 +2915,7 @@
           <p:cNvPr id="2" name="Title 1">
             <a:extLst>
               <a:ext uri="{FF2B5EF4-FFF2-40B4-BE49-F238E27FC236}">
-                <a16:creationId xmlns:a16="http://schemas.microsoft.com/office/drawing/2014/main" id="{C60C6A75-5234-4D25-05D8-7AA254026DCC}"/>
+                <a16:creationId xmlns:a16="http://schemas.microsoft.com/office/drawing/2014/main" id="{B24B34B0-1818-9D9C-F34C-17CC3B8AD5BB}"/>
               </a:ext>
             </a:extLst>
           </p:cNvPr>
@@ -2948,7 +2948,7 @@
           <p:cNvPr id="3" name="Text Placeholder 2">
             <a:extLst>
               <a:ext uri="{FF2B5EF4-FFF2-40B4-BE49-F238E27FC236}">
-                <a16:creationId xmlns:a16="http://schemas.microsoft.com/office/drawing/2014/main" id="{B77F9D73-60D0-3A38-B953-21A0B0540540}"/>
+                <a16:creationId xmlns:a16="http://schemas.microsoft.com/office/drawing/2014/main" id="{204CDDBF-F7AD-A8BC-F535-D084697F37F5}"/>
               </a:ext>
             </a:extLst>
           </p:cNvPr>
@@ -3019,7 +3019,7 @@
           <p:cNvPr id="4" name="Content Placeholder 3">
             <a:extLst>
               <a:ext uri="{FF2B5EF4-FFF2-40B4-BE49-F238E27FC236}">
-                <a16:creationId xmlns:a16="http://schemas.microsoft.com/office/drawing/2014/main" id="{1BBAFC41-1F4A-E108-5A80-E0217BC3A084}"/>
+                <a16:creationId xmlns:a16="http://schemas.microsoft.com/office/drawing/2014/main" id="{42657225-CDFE-2B42-E4F8-06DDE2EB188B}"/>
               </a:ext>
             </a:extLst>
           </p:cNvPr>
@@ -3081,7 +3081,7 @@
           <p:cNvPr id="5" name="Text Placeholder 4">
             <a:extLst>
               <a:ext uri="{FF2B5EF4-FFF2-40B4-BE49-F238E27FC236}">
-                <a16:creationId xmlns:a16="http://schemas.microsoft.com/office/drawing/2014/main" id="{875E0254-77FD-6705-2277-EE7F10B299C3}"/>
+                <a16:creationId xmlns:a16="http://schemas.microsoft.com/office/drawing/2014/main" id="{C12C40E5-BAA9-C5DA-EF29-B063D9080CE5}"/>
               </a:ext>
             </a:extLst>
           </p:cNvPr>
@@ -3152,7 +3152,7 @@
           <p:cNvPr id="6" name="Content Placeholder 5">
             <a:extLst>
               <a:ext uri="{FF2B5EF4-FFF2-40B4-BE49-F238E27FC236}">
-                <a16:creationId xmlns:a16="http://schemas.microsoft.com/office/drawing/2014/main" id="{3CEDBB75-3CEA-6DB9-4961-2E9E35D54AC0}"/>
+                <a16:creationId xmlns:a16="http://schemas.microsoft.com/office/drawing/2014/main" id="{EB9E515A-6B96-8591-7545-E1D0C13E870D}"/>
               </a:ext>
             </a:extLst>
           </p:cNvPr>
@@ -3214,7 +3214,7 @@
           <p:cNvPr id="7" name="Date Placeholder 6">
             <a:extLst>
               <a:ext uri="{FF2B5EF4-FFF2-40B4-BE49-F238E27FC236}">
-                <a16:creationId xmlns:a16="http://schemas.microsoft.com/office/drawing/2014/main" id="{F82F5D8C-A5AB-9C29-F2BE-211B5BBA56B9}"/>
+                <a16:creationId xmlns:a16="http://schemas.microsoft.com/office/drawing/2014/main" id="{5719AC98-2301-7576-A04B-98CD5AAE2EC5}"/>
               </a:ext>
             </a:extLst>
           </p:cNvPr>
@@ -3230,7 +3230,7 @@
           <a:bodyPr/>
           <a:lstStyle/>
           <a:p>
-            <a:fld id="{395A4AE7-3451-4A8F-875B-C3782B0A52A7}" type="datetimeFigureOut">
+            <a:fld id="{40FDD52B-EF56-4BB9-AE32-CBE6B0F3120F}" type="datetimeFigureOut">
               <a:rPr lang="en-US" smtClean="0"/>
               <a:t>10/1/2026</a:t>
             </a:fld>
@@ -3243,7 +3243,7 @@
           <p:cNvPr id="8" name="Footer Placeholder 7">
             <a:extLst>
               <a:ext uri="{FF2B5EF4-FFF2-40B4-BE49-F238E27FC236}">
-                <a16:creationId xmlns:a16="http://schemas.microsoft.com/office/drawing/2014/main" id="{F8963CB3-3685-7C67-EA03-D1DD60FA878B}"/>
+                <a16:creationId xmlns:a16="http://schemas.microsoft.com/office/drawing/2014/main" id="{B5966B85-B403-03B6-B519-917F62BFC800}"/>
               </a:ext>
             </a:extLst>
           </p:cNvPr>
@@ -3268,7 +3268,7 @@
           <p:cNvPr id="9" name="Slide Number Placeholder 8">
             <a:extLst>
               <a:ext uri="{FF2B5EF4-FFF2-40B4-BE49-F238E27FC236}">
-                <a16:creationId xmlns:a16="http://schemas.microsoft.com/office/drawing/2014/main" id="{D66D0C3C-2CC7-B4D0-BAA1-2E6271E99F9B}"/>
+                <a16:creationId xmlns:a16="http://schemas.microsoft.com/office/drawing/2014/main" id="{9BE8C983-69A3-3D65-7956-E50D1A8D3943}"/>
               </a:ext>
             </a:extLst>
           </p:cNvPr>
@@ -3284,7 +3284,7 @@
           <a:bodyPr/>
           <a:lstStyle/>
           <a:p>
-            <a:fld id="{F4536191-D2F0-4211-9D2E-0A00F1F7E313}" type="slidenum">
+            <a:fld id="{071C626E-CE99-4A38-B122-F832429FE450}" type="slidenum">
               <a:rPr lang="en-US" smtClean="0"/>
               <a:t>‹#›</a:t>
             </a:fld>
@@ -3295,7 +3295,7 @@
     </p:spTree>
     <p:extLst>
       <p:ext uri="{BB962C8B-B14F-4D97-AF65-F5344CB8AC3E}">
-        <p14:creationId xmlns:p14="http://schemas.microsoft.com/office/powerpoint/2010/main" val="506031716"/>
+        <p14:creationId xmlns:p14="http://schemas.microsoft.com/office/powerpoint/2010/main" val="316794708"/>
       </p:ext>
     </p:extLst>
   </p:cSld>
@@ -3327,7 +3327,7 @@
           <p:cNvPr id="2" name="Title 1">
             <a:extLst>
               <a:ext uri="{FF2B5EF4-FFF2-40B4-BE49-F238E27FC236}">
-                <a16:creationId xmlns:a16="http://schemas.microsoft.com/office/drawing/2014/main" id="{016F56B6-C3F2-BCFE-3ADD-29D168F7BC38}"/>
+                <a16:creationId xmlns:a16="http://schemas.microsoft.com/office/drawing/2014/main" id="{E97B25FB-BDBA-9B32-EC3D-4A9E5B6D3801}"/>
               </a:ext>
             </a:extLst>
           </p:cNvPr>
@@ -3355,7 +3355,7 @@
           <p:cNvPr id="3" name="Date Placeholder 2">
             <a:extLst>
               <a:ext uri="{FF2B5EF4-FFF2-40B4-BE49-F238E27FC236}">
-                <a16:creationId xmlns:a16="http://schemas.microsoft.com/office/drawing/2014/main" id="{AC9F6CDE-4466-44C7-335B-C43039FFA759}"/>
+                <a16:creationId xmlns:a16="http://schemas.microsoft.com/office/drawing/2014/main" id="{AC7E1AC7-DCBF-93F9-1ECE-883AA441AF69}"/>
               </a:ext>
             </a:extLst>
           </p:cNvPr>
@@ -3371,7 +3371,7 @@
           <a:bodyPr/>
           <a:lstStyle/>
           <a:p>
-            <a:fld id="{395A4AE7-3451-4A8F-875B-C3782B0A52A7}" type="datetimeFigureOut">
+            <a:fld id="{40FDD52B-EF56-4BB9-AE32-CBE6B0F3120F}" type="datetimeFigureOut">
               <a:rPr lang="en-US" smtClean="0"/>
               <a:t>10/1/2026</a:t>
             </a:fld>
@@ -3384,7 +3384,7 @@
           <p:cNvPr id="4" name="Footer Placeholder 3">
             <a:extLst>
               <a:ext uri="{FF2B5EF4-FFF2-40B4-BE49-F238E27FC236}">
-                <a16:creationId xmlns:a16="http://schemas.microsoft.com/office/drawing/2014/main" id="{B7DED776-1029-78D0-865D-EE4D1BF2667E}"/>
+                <a16:creationId xmlns:a16="http://schemas.microsoft.com/office/drawing/2014/main" id="{C112E9B1-42E8-5D05-4BA0-8BF380DAE3A7}"/>
               </a:ext>
             </a:extLst>
           </p:cNvPr>
@@ -3409,7 +3409,7 @@
           <p:cNvPr id="5" name="Slide Number Placeholder 4">
             <a:extLst>
               <a:ext uri="{FF2B5EF4-FFF2-40B4-BE49-F238E27FC236}">
-                <a16:creationId xmlns:a16="http://schemas.microsoft.com/office/drawing/2014/main" id="{E1B37AB4-0418-2B58-789E-AD1CA9A3A22A}"/>
+                <a16:creationId xmlns:a16="http://schemas.microsoft.com/office/drawing/2014/main" id="{F441597A-1062-298F-3B52-CD8F24000228}"/>
               </a:ext>
             </a:extLst>
           </p:cNvPr>
@@ -3425,7 +3425,7 @@
           <a:bodyPr/>
           <a:lstStyle/>
           <a:p>
-            <a:fld id="{F4536191-D2F0-4211-9D2E-0A00F1F7E313}" type="slidenum">
+            <a:fld id="{071C626E-CE99-4A38-B122-F832429FE450}" type="slidenum">
               <a:rPr lang="en-US" smtClean="0"/>
               <a:t>‹#›</a:t>
             </a:fld>
@@ -3436,7 +3436,7 @@
     </p:spTree>
     <p:extLst>
       <p:ext uri="{BB962C8B-B14F-4D97-AF65-F5344CB8AC3E}">
-        <p14:creationId xmlns:p14="http://schemas.microsoft.com/office/powerpoint/2010/main" val="1070947993"/>
+        <p14:creationId xmlns:p14="http://schemas.microsoft.com/office/powerpoint/2010/main" val="2091304017"/>
       </p:ext>
     </p:extLst>
   </p:cSld>
@@ -3468,7 +3468,7 @@
           <p:cNvPr id="2" name="Date Placeholder 1">
             <a:extLst>
               <a:ext uri="{FF2B5EF4-FFF2-40B4-BE49-F238E27FC236}">
-                <a16:creationId xmlns:a16="http://schemas.microsoft.com/office/drawing/2014/main" id="{CB691651-935C-9A4D-3E0A-973B6F6527A8}"/>
+                <a16:creationId xmlns:a16="http://schemas.microsoft.com/office/drawing/2014/main" id="{C56E8F79-823E-E26B-EBD4-552EC2EB588E}"/>
               </a:ext>
             </a:extLst>
           </p:cNvPr>
@@ -3484,7 +3484,7 @@
           <a:bodyPr/>
           <a:lstStyle/>
           <a:p>
-            <a:fld id="{395A4AE7-3451-4A8F-875B-C3782B0A52A7}" type="datetimeFigureOut">
+            <a:fld id="{40FDD52B-EF56-4BB9-AE32-CBE6B0F3120F}" type="datetimeFigureOut">
               <a:rPr lang="en-US" smtClean="0"/>
               <a:t>10/1/2026</a:t>
             </a:fld>
@@ -3497,7 +3497,7 @@
           <p:cNvPr id="3" name="Footer Placeholder 2">
             <a:extLst>
               <a:ext uri="{FF2B5EF4-FFF2-40B4-BE49-F238E27FC236}">
-                <a16:creationId xmlns:a16="http://schemas.microsoft.com/office/drawing/2014/main" id="{6C4AF077-2AD2-95DC-F2D9-FCAC7C59D7C8}"/>
+                <a16:creationId xmlns:a16="http://schemas.microsoft.com/office/drawing/2014/main" id="{AB4829A9-334D-586A-CF5E-8827B3C4CC4E}"/>
               </a:ext>
             </a:extLst>
           </p:cNvPr>
@@ -3522,7 +3522,7 @@
           <p:cNvPr id="4" name="Slide Number Placeholder 3">
             <a:extLst>
               <a:ext uri="{FF2B5EF4-FFF2-40B4-BE49-F238E27FC236}">
-                <a16:creationId xmlns:a16="http://schemas.microsoft.com/office/drawing/2014/main" id="{A6B7222E-8FA8-CCA5-1507-A536FA6489F3}"/>
+                <a16:creationId xmlns:a16="http://schemas.microsoft.com/office/drawing/2014/main" id="{59335FA4-9BC7-8A76-5973-1FAC5826EC10}"/>
               </a:ext>
             </a:extLst>
           </p:cNvPr>
@@ -3538,7 +3538,7 @@
           <a:bodyPr/>
           <a:lstStyle/>
           <a:p>
-            <a:fld id="{F4536191-D2F0-4211-9D2E-0A00F1F7E313}" type="slidenum">
+            <a:fld id="{071C626E-CE99-4A38-B122-F832429FE450}" type="slidenum">
               <a:rPr lang="en-US" smtClean="0"/>
               <a:t>‹#›</a:t>
             </a:fld>
@@ -3549,7 +3549,7 @@
     </p:spTree>
     <p:extLst>
       <p:ext uri="{BB962C8B-B14F-4D97-AF65-F5344CB8AC3E}">
-        <p14:creationId xmlns:p14="http://schemas.microsoft.com/office/powerpoint/2010/main" val="960541668"/>
+        <p14:creationId xmlns:p14="http://schemas.microsoft.com/office/powerpoint/2010/main" val="1158616035"/>
       </p:ext>
     </p:extLst>
   </p:cSld>
@@ -3581,7 +3581,7 @@
           <p:cNvPr id="2" name="Title 1">
             <a:extLst>
               <a:ext uri="{FF2B5EF4-FFF2-40B4-BE49-F238E27FC236}">
-                <a16:creationId xmlns:a16="http://schemas.microsoft.com/office/drawing/2014/main" id="{1ECCA890-64D4-EBA8-35A8-766188B222F3}"/>
+                <a16:creationId xmlns:a16="http://schemas.microsoft.com/office/drawing/2014/main" id="{BFD3FD00-4636-9536-B2EC-D0A5AA0D1151}"/>
               </a:ext>
             </a:extLst>
           </p:cNvPr>
@@ -3618,7 +3618,7 @@
           <p:cNvPr id="3" name="Content Placeholder 2">
             <a:extLst>
               <a:ext uri="{FF2B5EF4-FFF2-40B4-BE49-F238E27FC236}">
-                <a16:creationId xmlns:a16="http://schemas.microsoft.com/office/drawing/2014/main" id="{C645D138-24D2-6A50-4ACD-F73128617654}"/>
+                <a16:creationId xmlns:a16="http://schemas.microsoft.com/office/drawing/2014/main" id="{BB1DA060-3AA9-8009-606D-92C2EBB9C0A6}"/>
               </a:ext>
             </a:extLst>
           </p:cNvPr>
@@ -3708,7 +3708,7 @@
           <p:cNvPr id="4" name="Text Placeholder 3">
             <a:extLst>
               <a:ext uri="{FF2B5EF4-FFF2-40B4-BE49-F238E27FC236}">
-                <a16:creationId xmlns:a16="http://schemas.microsoft.com/office/drawing/2014/main" id="{632E664A-566E-17D8-D4DE-5DA8ECAE92F1}"/>
+                <a16:creationId xmlns:a16="http://schemas.microsoft.com/office/drawing/2014/main" id="{36378030-12C9-E018-5A89-E2995160D74D}"/>
               </a:ext>
             </a:extLst>
           </p:cNvPr>
@@ -3779,7 +3779,7 @@
           <p:cNvPr id="5" name="Date Placeholder 4">
             <a:extLst>
               <a:ext uri="{FF2B5EF4-FFF2-40B4-BE49-F238E27FC236}">
-                <a16:creationId xmlns:a16="http://schemas.microsoft.com/office/drawing/2014/main" id="{782A60AB-C702-48D0-B06E-867830C99DA5}"/>
+                <a16:creationId xmlns:a16="http://schemas.microsoft.com/office/drawing/2014/main" id="{810C94AD-9BF8-E5C5-F5E3-20C5701BF1EA}"/>
               </a:ext>
             </a:extLst>
           </p:cNvPr>
@@ -3795,7 +3795,7 @@
           <a:bodyPr/>
           <a:lstStyle/>
           <a:p>
-            <a:fld id="{395A4AE7-3451-4A8F-875B-C3782B0A52A7}" type="datetimeFigureOut">
+            <a:fld id="{40FDD52B-EF56-4BB9-AE32-CBE6B0F3120F}" type="datetimeFigureOut">
               <a:rPr lang="en-US" smtClean="0"/>
               <a:t>10/1/2026</a:t>
             </a:fld>
@@ -3808,7 +3808,7 @@
           <p:cNvPr id="6" name="Footer Placeholder 5">
             <a:extLst>
               <a:ext uri="{FF2B5EF4-FFF2-40B4-BE49-F238E27FC236}">
-                <a16:creationId xmlns:a16="http://schemas.microsoft.com/office/drawing/2014/main" id="{0352AB15-FA84-5CBA-04B6-89FBB259C905}"/>
+                <a16:creationId xmlns:a16="http://schemas.microsoft.com/office/drawing/2014/main" id="{C57C24F1-68FA-3AFB-36DC-65953C588EA4}"/>
               </a:ext>
             </a:extLst>
           </p:cNvPr>
@@ -3833,7 +3833,7 @@
           <p:cNvPr id="7" name="Slide Number Placeholder 6">
             <a:extLst>
               <a:ext uri="{FF2B5EF4-FFF2-40B4-BE49-F238E27FC236}">
-                <a16:creationId xmlns:a16="http://schemas.microsoft.com/office/drawing/2014/main" id="{07F2EE5C-9584-F1FC-7315-EDC487E52E87}"/>
+                <a16:creationId xmlns:a16="http://schemas.microsoft.com/office/drawing/2014/main" id="{10D8DD79-A460-7C8E-AE52-C1AC3FC1DEAE}"/>
               </a:ext>
             </a:extLst>
           </p:cNvPr>
@@ -3849,7 +3849,7 @@
           <a:bodyPr/>
           <a:lstStyle/>
           <a:p>
-            <a:fld id="{F4536191-D2F0-4211-9D2E-0A00F1F7E313}" type="slidenum">
+            <a:fld id="{071C626E-CE99-4A38-B122-F832429FE450}" type="slidenum">
               <a:rPr lang="en-US" smtClean="0"/>
               <a:t>‹#›</a:t>
             </a:fld>
@@ -3860,7 +3860,7 @@
     </p:spTree>
     <p:extLst>
       <p:ext uri="{BB962C8B-B14F-4D97-AF65-F5344CB8AC3E}">
-        <p14:creationId xmlns:p14="http://schemas.microsoft.com/office/powerpoint/2010/main" val="888248127"/>
+        <p14:creationId xmlns:p14="http://schemas.microsoft.com/office/powerpoint/2010/main" val="1463744899"/>
       </p:ext>
     </p:extLst>
   </p:cSld>
@@ -3892,7 +3892,7 @@
           <p:cNvPr id="2" name="Title 1">
             <a:extLst>
               <a:ext uri="{FF2B5EF4-FFF2-40B4-BE49-F238E27FC236}">
-                <a16:creationId xmlns:a16="http://schemas.microsoft.com/office/drawing/2014/main" id="{BC371D28-ECF0-444A-0FE2-2FB9F11E0734}"/>
+                <a16:creationId xmlns:a16="http://schemas.microsoft.com/office/drawing/2014/main" id="{2A64B45A-0C98-5A3D-F3A5-6EBB28308C04}"/>
               </a:ext>
             </a:extLst>
           </p:cNvPr>
@@ -3929,7 +3929,7 @@
           <p:cNvPr id="3" name="Picture Placeholder 2">
             <a:extLst>
               <a:ext uri="{FF2B5EF4-FFF2-40B4-BE49-F238E27FC236}">
-                <a16:creationId xmlns:a16="http://schemas.microsoft.com/office/drawing/2014/main" id="{C4EADA07-46A6-4E4E-DB49-485F86EFBC21}"/>
+                <a16:creationId xmlns:a16="http://schemas.microsoft.com/office/drawing/2014/main" id="{C6FC84CC-B153-30F3-3E0D-5AC57F367D01}"/>
               </a:ext>
             </a:extLst>
           </p:cNvPr>
@@ -3996,7 +3996,7 @@
           <p:cNvPr id="4" name="Text Placeholder 3">
             <a:extLst>
               <a:ext uri="{FF2B5EF4-FFF2-40B4-BE49-F238E27FC236}">
-                <a16:creationId xmlns:a16="http://schemas.microsoft.com/office/drawing/2014/main" id="{262373DF-A5D1-2A06-B82D-0D1EC40F7CD8}"/>
+                <a16:creationId xmlns:a16="http://schemas.microsoft.com/office/drawing/2014/main" id="{414C229A-5F28-9E19-6213-47E08E5E0072}"/>
               </a:ext>
             </a:extLst>
           </p:cNvPr>
@@ -4067,7 +4067,7 @@
           <p:cNvPr id="5" name="Date Placeholder 4">
             <a:extLst>
               <a:ext uri="{FF2B5EF4-FFF2-40B4-BE49-F238E27FC236}">
-                <a16:creationId xmlns:a16="http://schemas.microsoft.com/office/drawing/2014/main" id="{0CC16F67-C08B-B84D-6B9E-A2F5E8CC6EC7}"/>
+                <a16:creationId xmlns:a16="http://schemas.microsoft.com/office/drawing/2014/main" id="{03B31EEE-C29E-DCEE-50C7-E6A899265DC4}"/>
               </a:ext>
             </a:extLst>
           </p:cNvPr>
@@ -4083,7 +4083,7 @@
           <a:bodyPr/>
           <a:lstStyle/>
           <a:p>
-            <a:fld id="{395A4AE7-3451-4A8F-875B-C3782B0A52A7}" type="datetimeFigureOut">
+            <a:fld id="{40FDD52B-EF56-4BB9-AE32-CBE6B0F3120F}" type="datetimeFigureOut">
               <a:rPr lang="en-US" smtClean="0"/>
               <a:t>10/1/2026</a:t>
             </a:fld>
@@ -4096,7 +4096,7 @@
           <p:cNvPr id="6" name="Footer Placeholder 5">
             <a:extLst>
               <a:ext uri="{FF2B5EF4-FFF2-40B4-BE49-F238E27FC236}">
-                <a16:creationId xmlns:a16="http://schemas.microsoft.com/office/drawing/2014/main" id="{89773F99-1530-F215-1BE3-7562BD74E67E}"/>
+                <a16:creationId xmlns:a16="http://schemas.microsoft.com/office/drawing/2014/main" id="{9B095FD4-6BE0-8194-1178-D760D26DAF4F}"/>
               </a:ext>
             </a:extLst>
           </p:cNvPr>
@@ -4121,7 +4121,7 @@
           <p:cNvPr id="7" name="Slide Number Placeholder 6">
             <a:extLst>
               <a:ext uri="{FF2B5EF4-FFF2-40B4-BE49-F238E27FC236}">
-                <a16:creationId xmlns:a16="http://schemas.microsoft.com/office/drawing/2014/main" id="{B82DA260-2C5C-2308-E080-E4B9F43DA99D}"/>
+                <a16:creationId xmlns:a16="http://schemas.microsoft.com/office/drawing/2014/main" id="{E91EF188-050E-BD91-24F4-80B95A670990}"/>
               </a:ext>
             </a:extLst>
           </p:cNvPr>
@@ -4137,7 +4137,7 @@
           <a:bodyPr/>
           <a:lstStyle/>
           <a:p>
-            <a:fld id="{F4536191-D2F0-4211-9D2E-0A00F1F7E313}" type="slidenum">
+            <a:fld id="{071C626E-CE99-4A38-B122-F832429FE450}" type="slidenum">
               <a:rPr lang="en-US" smtClean="0"/>
               <a:t>‹#›</a:t>
             </a:fld>
@@ -4148,7 +4148,7 @@
     </p:spTree>
     <p:extLst>
       <p:ext uri="{BB962C8B-B14F-4D97-AF65-F5344CB8AC3E}">
-        <p14:creationId xmlns:p14="http://schemas.microsoft.com/office/powerpoint/2010/main" val="1711018512"/>
+        <p14:creationId xmlns:p14="http://schemas.microsoft.com/office/powerpoint/2010/main" val="4085787594"/>
       </p:ext>
     </p:extLst>
   </p:cSld>
@@ -4185,7 +4185,7 @@
           <p:cNvPr id="2" name="Title Placeholder 1">
             <a:extLst>
               <a:ext uri="{FF2B5EF4-FFF2-40B4-BE49-F238E27FC236}">
-                <a16:creationId xmlns:a16="http://schemas.microsoft.com/office/drawing/2014/main" id="{721364AE-66BD-B208-0273-AD6ED2044539}"/>
+                <a16:creationId xmlns:a16="http://schemas.microsoft.com/office/drawing/2014/main" id="{C07B5455-94E0-61A4-CD52-228A8DA3CD4D}"/>
               </a:ext>
             </a:extLst>
           </p:cNvPr>
@@ -4223,7 +4223,7 @@
           <p:cNvPr id="3" name="Text Placeholder 2">
             <a:extLst>
               <a:ext uri="{FF2B5EF4-FFF2-40B4-BE49-F238E27FC236}">
-                <a16:creationId xmlns:a16="http://schemas.microsoft.com/office/drawing/2014/main" id="{48C6EE77-DD74-0635-9AEA-BD29DA6B866C}"/>
+                <a16:creationId xmlns:a16="http://schemas.microsoft.com/office/drawing/2014/main" id="{2F14C237-B534-8552-5592-2DA2614AD311}"/>
               </a:ext>
             </a:extLst>
           </p:cNvPr>
@@ -4290,7 +4290,7 @@
           <p:cNvPr id="4" name="Date Placeholder 3">
             <a:extLst>
               <a:ext uri="{FF2B5EF4-FFF2-40B4-BE49-F238E27FC236}">
-                <a16:creationId xmlns:a16="http://schemas.microsoft.com/office/drawing/2014/main" id="{988C5071-748D-EEFC-E61C-70C99432FFE3}"/>
+                <a16:creationId xmlns:a16="http://schemas.microsoft.com/office/drawing/2014/main" id="{0D43DDEF-9B98-5310-3D3C-1B18B9E7CD64}"/>
               </a:ext>
             </a:extLst>
           </p:cNvPr>
@@ -4324,7 +4324,7 @@
             </a:lvl1pPr>
           </a:lstStyle>
           <a:p>
-            <a:fld id="{395A4AE7-3451-4A8F-875B-C3782B0A52A7}" type="datetimeFigureOut">
+            <a:fld id="{40FDD52B-EF56-4BB9-AE32-CBE6B0F3120F}" type="datetimeFigureOut">
               <a:rPr lang="en-US" smtClean="0"/>
               <a:t>10/1/2026</a:t>
             </a:fld>
@@ -4337,7 +4337,7 @@
           <p:cNvPr id="5" name="Footer Placeholder 4">
             <a:extLst>
               <a:ext uri="{FF2B5EF4-FFF2-40B4-BE49-F238E27FC236}">
-                <a16:creationId xmlns:a16="http://schemas.microsoft.com/office/drawing/2014/main" id="{1A872707-C35E-4A0E-1DEB-AA32D8073252}"/>
+                <a16:creationId xmlns:a16="http://schemas.microsoft.com/office/drawing/2014/main" id="{97A88907-99B9-4EC5-B906-AA657037F0BA}"/>
               </a:ext>
             </a:extLst>
           </p:cNvPr>
@@ -4380,7 +4380,7 @@
           <p:cNvPr id="6" name="Slide Number Placeholder 5">
             <a:extLst>
               <a:ext uri="{FF2B5EF4-FFF2-40B4-BE49-F238E27FC236}">
-                <a16:creationId xmlns:a16="http://schemas.microsoft.com/office/drawing/2014/main" id="{0626AAF8-7787-BB54-2B80-CC50BBC4E15D}"/>
+                <a16:creationId xmlns:a16="http://schemas.microsoft.com/office/drawing/2014/main" id="{98CA262E-6FA5-E039-185B-532A29A63D94}"/>
               </a:ext>
             </a:extLst>
           </p:cNvPr>
@@ -4414,7 +4414,7 @@
             </a:lvl1pPr>
           </a:lstStyle>
           <a:p>
-            <a:fld id="{F4536191-D2F0-4211-9D2E-0A00F1F7E313}" type="slidenum">
+            <a:fld id="{071C626E-CE99-4A38-B122-F832429FE450}" type="slidenum">
               <a:rPr lang="en-US" smtClean="0"/>
               <a:t>‹#›</a:t>
             </a:fld>
@@ -4425,7 +4425,7 @@
     </p:spTree>
     <p:extLst>
       <p:ext uri="{BB962C8B-B14F-4D97-AF65-F5344CB8AC3E}">
-        <p14:creationId xmlns:p14="http://schemas.microsoft.com/office/powerpoint/2010/main" val="3846737490"/>
+        <p14:creationId xmlns:p14="http://schemas.microsoft.com/office/powerpoint/2010/main" val="1738204650"/>
       </p:ext>
     </p:extLst>
   </p:cSld>
@@ -4748,7 +4748,7 @@
           <p:cNvPr id="2" name="Rectangle 1">
             <a:extLst>
               <a:ext uri="{FF2B5EF4-FFF2-40B4-BE49-F238E27FC236}">
-                <a16:creationId xmlns:a16="http://schemas.microsoft.com/office/drawing/2014/main" id="{406849EB-0282-D28F-AE63-1C8710B21493}"/>
+                <a16:creationId xmlns:a16="http://schemas.microsoft.com/office/drawing/2014/main" id="{99AD4373-A7FD-8A9E-1359-6907F793B6B7}"/>
               </a:ext>
             </a:extLst>
           </p:cNvPr>
@@ -4816,7 +4816,7 @@
           <p:cNvPr id="3" name="Rectangle 2">
             <a:extLst>
               <a:ext uri="{FF2B5EF4-FFF2-40B4-BE49-F238E27FC236}">
-                <a16:creationId xmlns:a16="http://schemas.microsoft.com/office/drawing/2014/main" id="{D68714D2-3DFB-0AD2-1B34-75A5B4D7B392}"/>
+                <a16:creationId xmlns:a16="http://schemas.microsoft.com/office/drawing/2014/main" id="{FAE390E4-4560-D1F1-2612-7AC9B8492908}"/>
               </a:ext>
             </a:extLst>
           </p:cNvPr>
@@ -4884,7 +4884,7 @@
           <p:cNvPr id="4" name="TextBox 3">
             <a:extLst>
               <a:ext uri="{FF2B5EF4-FFF2-40B4-BE49-F238E27FC236}">
-                <a16:creationId xmlns:a16="http://schemas.microsoft.com/office/drawing/2014/main" id="{BFD0D914-7EB2-A7F9-9159-D59729C22DA5}"/>
+                <a16:creationId xmlns:a16="http://schemas.microsoft.com/office/drawing/2014/main" id="{6332B4BB-18BF-B2B7-082C-A92B17008C4B}"/>
               </a:ext>
             </a:extLst>
           </p:cNvPr>
@@ -4935,7 +4935,7 @@
           <p:cNvPr id="5" name="TextBox 4">
             <a:extLst>
               <a:ext uri="{FF2B5EF4-FFF2-40B4-BE49-F238E27FC236}">
-                <a16:creationId xmlns:a16="http://schemas.microsoft.com/office/drawing/2014/main" id="{03FCFDA3-1266-CB4C-D40A-D34AAEC31739}"/>
+                <a16:creationId xmlns:a16="http://schemas.microsoft.com/office/drawing/2014/main" id="{D2572A4C-1FF8-C508-88DA-1EA29162DD76}"/>
               </a:ext>
             </a:extLst>
           </p:cNvPr>
@@ -5000,7 +5000,7 @@
           <p:cNvPr id="6" name="TextBox 5">
             <a:extLst>
               <a:ext uri="{FF2B5EF4-FFF2-40B4-BE49-F238E27FC236}">
-                <a16:creationId xmlns:a16="http://schemas.microsoft.com/office/drawing/2014/main" id="{4BE27E42-1FA4-32BA-64A0-E5952C149BD6}"/>
+                <a16:creationId xmlns:a16="http://schemas.microsoft.com/office/drawing/2014/main" id="{A8257E9B-2887-C0BA-B88B-B9C861EB037F}"/>
               </a:ext>
             </a:extLst>
           </p:cNvPr>
@@ -5068,7 +5068,7 @@
                 <a:latin typeface="Segoe UI" panose="020B0502040204020203" pitchFamily="34" charset="0"/>
               </a:rPr>
               <a:t>شهرياً (36.8 مليون ج.م سنوياً لعام 2027)
-إعداد: مدير المنطقة البيعية (</a:t>
+إعداد: عبدالله أحمد إبراهيم — مدير المنطقة البيعية (</a:t>
             </a:r>
             <a:r>
               <a:rPr lang="en-US" sz="1400">
@@ -5085,7 +5085,7 @@
     </p:spTree>
     <p:extLst>
       <p:ext uri="{BB962C8B-B14F-4D97-AF65-F5344CB8AC3E}">
-        <p14:creationId xmlns:p14="http://schemas.microsoft.com/office/powerpoint/2010/main" val="2211928406"/>
+        <p14:creationId xmlns:p14="http://schemas.microsoft.com/office/powerpoint/2010/main" val="3732550319"/>
       </p:ext>
     </p:extLst>
   </p:cSld>
@@ -5117,7 +5117,7 @@
           <p:cNvPr id="2" name="Rectangle 1">
             <a:extLst>
               <a:ext uri="{FF2B5EF4-FFF2-40B4-BE49-F238E27FC236}">
-                <a16:creationId xmlns:a16="http://schemas.microsoft.com/office/drawing/2014/main" id="{A6918E26-CA1D-3DC2-F577-2CD2CB2DB212}"/>
+                <a16:creationId xmlns:a16="http://schemas.microsoft.com/office/drawing/2014/main" id="{6EC41341-72C9-ECAB-B97D-F4D2FF22B88F}"/>
               </a:ext>
             </a:extLst>
           </p:cNvPr>
@@ -5185,7 +5185,7 @@
           <p:cNvPr id="3" name="Rectangle 2">
             <a:extLst>
               <a:ext uri="{FF2B5EF4-FFF2-40B4-BE49-F238E27FC236}">
-                <a16:creationId xmlns:a16="http://schemas.microsoft.com/office/drawing/2014/main" id="{7D3CD786-02F6-0FEA-69CA-58D4F85F96F6}"/>
+                <a16:creationId xmlns:a16="http://schemas.microsoft.com/office/drawing/2014/main" id="{8662BE85-A257-3062-3451-044BCC8C0A86}"/>
               </a:ext>
             </a:extLst>
           </p:cNvPr>
@@ -5253,7 +5253,7 @@
           <p:cNvPr id="4" name="TextBox 3">
             <a:extLst>
               <a:ext uri="{FF2B5EF4-FFF2-40B4-BE49-F238E27FC236}">
-                <a16:creationId xmlns:a16="http://schemas.microsoft.com/office/drawing/2014/main" id="{EFE659F1-87FC-BDC3-077E-B5D02F0C6509}"/>
+                <a16:creationId xmlns:a16="http://schemas.microsoft.com/office/drawing/2014/main" id="{C0D74C91-BE86-6CFD-8564-43314E642030}"/>
               </a:ext>
             </a:extLst>
           </p:cNvPr>
@@ -5321,7 +5321,7 @@
           <p:cNvPr id="5" name="TextBox 4">
             <a:extLst>
               <a:ext uri="{FF2B5EF4-FFF2-40B4-BE49-F238E27FC236}">
-                <a16:creationId xmlns:a16="http://schemas.microsoft.com/office/drawing/2014/main" id="{BFDBA28E-D837-F781-FEBF-90194BF0C446}"/>
+                <a16:creationId xmlns:a16="http://schemas.microsoft.com/office/drawing/2014/main" id="{89B73F45-D917-BF17-BBE1-CA02163BD41C}"/>
               </a:ext>
             </a:extLst>
           </p:cNvPr>
@@ -5368,7 +5368,7 @@
           <p:cNvPr id="6" name="TextBox 5">
             <a:extLst>
               <a:ext uri="{FF2B5EF4-FFF2-40B4-BE49-F238E27FC236}">
-                <a16:creationId xmlns:a16="http://schemas.microsoft.com/office/drawing/2014/main" id="{293E83BF-9D8C-E625-79E3-19FAAF75371A}"/>
+                <a16:creationId xmlns:a16="http://schemas.microsoft.com/office/drawing/2014/main" id="{C9DE7EF1-6F61-B8CE-9F86-F09A67DA4D13}"/>
               </a:ext>
             </a:extLst>
           </p:cNvPr>
@@ -5408,7 +5408,7 @@
           <p:cNvPr id="7" name="Rectangle: Rounded Corners 6">
             <a:extLst>
               <a:ext uri="{FF2B5EF4-FFF2-40B4-BE49-F238E27FC236}">
-                <a16:creationId xmlns:a16="http://schemas.microsoft.com/office/drawing/2014/main" id="{68B5250C-0AC4-B37D-D01D-8F42D54FB863}"/>
+                <a16:creationId xmlns:a16="http://schemas.microsoft.com/office/drawing/2014/main" id="{B3F41EC4-CA24-30E8-85AB-168217832E30}"/>
               </a:ext>
             </a:extLst>
           </p:cNvPr>
@@ -5462,7 +5462,7 @@
           <p:cNvPr id="8" name="TextBox 7">
             <a:extLst>
               <a:ext uri="{FF2B5EF4-FFF2-40B4-BE49-F238E27FC236}">
-                <a16:creationId xmlns:a16="http://schemas.microsoft.com/office/drawing/2014/main" id="{1EAAD570-6DA3-C222-6CB0-8065745D9DE9}"/>
+                <a16:creationId xmlns:a16="http://schemas.microsoft.com/office/drawing/2014/main" id="{1DD89531-7EAC-3CBF-93AB-41561C6ECAE7}"/>
               </a:ext>
             </a:extLst>
           </p:cNvPr>
@@ -5512,7 +5512,7 @@
           <p:cNvPr id="9" name="TextBox 8">
             <a:extLst>
               <a:ext uri="{FF2B5EF4-FFF2-40B4-BE49-F238E27FC236}">
-                <a16:creationId xmlns:a16="http://schemas.microsoft.com/office/drawing/2014/main" id="{050A437C-2B8E-34A0-7DD1-6CB17CC90175}"/>
+                <a16:creationId xmlns:a16="http://schemas.microsoft.com/office/drawing/2014/main" id="{9B9B8517-0276-2EBD-B24D-354357DF4282}"/>
               </a:ext>
             </a:extLst>
           </p:cNvPr>
@@ -5601,7 +5601,7 @@
           <p:cNvPr id="10" name="Rectangle: Rounded Corners 9">
             <a:extLst>
               <a:ext uri="{FF2B5EF4-FFF2-40B4-BE49-F238E27FC236}">
-                <a16:creationId xmlns:a16="http://schemas.microsoft.com/office/drawing/2014/main" id="{0A61BAAC-37DD-C34E-82E6-6FF513696948}"/>
+                <a16:creationId xmlns:a16="http://schemas.microsoft.com/office/drawing/2014/main" id="{133313C9-6251-9B14-EAD7-0D8C3AF903CB}"/>
               </a:ext>
             </a:extLst>
           </p:cNvPr>
@@ -5655,7 +5655,7 @@
           <p:cNvPr id="11" name="TextBox 10">
             <a:extLst>
               <a:ext uri="{FF2B5EF4-FFF2-40B4-BE49-F238E27FC236}">
-                <a16:creationId xmlns:a16="http://schemas.microsoft.com/office/drawing/2014/main" id="{229AF6C5-77F1-6508-3BCD-7E7358E29120}"/>
+                <a16:creationId xmlns:a16="http://schemas.microsoft.com/office/drawing/2014/main" id="{8CD6B6AB-2B7B-3931-5A5A-7A0259B54750}"/>
               </a:ext>
             </a:extLst>
           </p:cNvPr>
@@ -5705,7 +5705,7 @@
           <p:cNvPr id="12" name="TextBox 11">
             <a:extLst>
               <a:ext uri="{FF2B5EF4-FFF2-40B4-BE49-F238E27FC236}">
-                <a16:creationId xmlns:a16="http://schemas.microsoft.com/office/drawing/2014/main" id="{EBF4E13B-C4DA-A9AF-5968-57A14A6E154C}"/>
+                <a16:creationId xmlns:a16="http://schemas.microsoft.com/office/drawing/2014/main" id="{CA36A8EE-9265-54A3-7625-C76F33D727FD}"/>
               </a:ext>
             </a:extLst>
           </p:cNvPr>
@@ -5776,7 +5776,7 @@
           <p:cNvPr id="13" name="Rectangle: Rounded Corners 12">
             <a:extLst>
               <a:ext uri="{FF2B5EF4-FFF2-40B4-BE49-F238E27FC236}">
-                <a16:creationId xmlns:a16="http://schemas.microsoft.com/office/drawing/2014/main" id="{BB2BE14D-04C6-32A5-F482-B0EA21EF12FE}"/>
+                <a16:creationId xmlns:a16="http://schemas.microsoft.com/office/drawing/2014/main" id="{F5386795-5B04-8E97-F7FF-9F036BB6FABB}"/>
               </a:ext>
             </a:extLst>
           </p:cNvPr>
@@ -5830,7 +5830,7 @@
           <p:cNvPr id="14" name="TextBox 13">
             <a:extLst>
               <a:ext uri="{FF2B5EF4-FFF2-40B4-BE49-F238E27FC236}">
-                <a16:creationId xmlns:a16="http://schemas.microsoft.com/office/drawing/2014/main" id="{CC165F43-F785-5506-F885-7D1A027D5999}"/>
+                <a16:creationId xmlns:a16="http://schemas.microsoft.com/office/drawing/2014/main" id="{BBEEBAF9-70BE-3640-7A51-8011E240F9BE}"/>
               </a:ext>
             </a:extLst>
           </p:cNvPr>
@@ -5880,7 +5880,7 @@
           <p:cNvPr id="15" name="TextBox 14">
             <a:extLst>
               <a:ext uri="{FF2B5EF4-FFF2-40B4-BE49-F238E27FC236}">
-                <a16:creationId xmlns:a16="http://schemas.microsoft.com/office/drawing/2014/main" id="{48DC9195-BD57-679E-A5C9-B5240417E86F}"/>
+                <a16:creationId xmlns:a16="http://schemas.microsoft.com/office/drawing/2014/main" id="{39F9CB0F-12EE-B80A-07CF-79E4308885F3}"/>
               </a:ext>
             </a:extLst>
           </p:cNvPr>
@@ -5985,7 +5985,7 @@
     </p:spTree>
     <p:extLst>
       <p:ext uri="{BB962C8B-B14F-4D97-AF65-F5344CB8AC3E}">
-        <p14:creationId xmlns:p14="http://schemas.microsoft.com/office/powerpoint/2010/main" val="1878602207"/>
+        <p14:creationId xmlns:p14="http://schemas.microsoft.com/office/powerpoint/2010/main" val="1983146838"/>
       </p:ext>
     </p:extLst>
   </p:cSld>
@@ -6017,7 +6017,7 @@
           <p:cNvPr id="2" name="Rectangle 1">
             <a:extLst>
               <a:ext uri="{FF2B5EF4-FFF2-40B4-BE49-F238E27FC236}">
-                <a16:creationId xmlns:a16="http://schemas.microsoft.com/office/drawing/2014/main" id="{C7040EF1-5557-C7B6-D468-66645E3434B6}"/>
+                <a16:creationId xmlns:a16="http://schemas.microsoft.com/office/drawing/2014/main" id="{5D425EDB-4FAA-436F-71DD-42F803CDF2B9}"/>
               </a:ext>
             </a:extLst>
           </p:cNvPr>
@@ -6085,7 +6085,7 @@
           <p:cNvPr id="3" name="Rectangle 2">
             <a:extLst>
               <a:ext uri="{FF2B5EF4-FFF2-40B4-BE49-F238E27FC236}">
-                <a16:creationId xmlns:a16="http://schemas.microsoft.com/office/drawing/2014/main" id="{9FF2F667-876F-87AE-6868-B4EAF43C33C6}"/>
+                <a16:creationId xmlns:a16="http://schemas.microsoft.com/office/drawing/2014/main" id="{2597E468-D355-F1C1-2866-BE439D304160}"/>
               </a:ext>
             </a:extLst>
           </p:cNvPr>
@@ -6153,7 +6153,7 @@
           <p:cNvPr id="4" name="TextBox 3">
             <a:extLst>
               <a:ext uri="{FF2B5EF4-FFF2-40B4-BE49-F238E27FC236}">
-                <a16:creationId xmlns:a16="http://schemas.microsoft.com/office/drawing/2014/main" id="{6143A31F-3610-354E-262E-F71B55E7B83A}"/>
+                <a16:creationId xmlns:a16="http://schemas.microsoft.com/office/drawing/2014/main" id="{BD520D86-34B8-61C8-3BD5-7BF8463364BB}"/>
               </a:ext>
             </a:extLst>
           </p:cNvPr>
@@ -6221,7 +6221,7 @@
           <p:cNvPr id="5" name="TextBox 4">
             <a:extLst>
               <a:ext uri="{FF2B5EF4-FFF2-40B4-BE49-F238E27FC236}">
-                <a16:creationId xmlns:a16="http://schemas.microsoft.com/office/drawing/2014/main" id="{872AF5FA-2312-B271-FDF6-C56A04CA8CB5}"/>
+                <a16:creationId xmlns:a16="http://schemas.microsoft.com/office/drawing/2014/main" id="{8DB0EE62-7FFD-A70C-1BE3-06B989455F26}"/>
               </a:ext>
             </a:extLst>
           </p:cNvPr>
@@ -6286,7 +6286,7 @@
           <p:cNvPr id="6" name="TextBox 5">
             <a:extLst>
               <a:ext uri="{FF2B5EF4-FFF2-40B4-BE49-F238E27FC236}">
-                <a16:creationId xmlns:a16="http://schemas.microsoft.com/office/drawing/2014/main" id="{A978D38A-977C-9933-62E5-D3F0E8FED243}"/>
+                <a16:creationId xmlns:a16="http://schemas.microsoft.com/office/drawing/2014/main" id="{C6C601AD-9398-F4AC-EB40-9E45A64824EB}"/>
               </a:ext>
             </a:extLst>
           </p:cNvPr>
@@ -6326,7 +6326,7 @@
           <p:cNvPr id="7" name="Rectangle: Rounded Corners 6">
             <a:extLst>
               <a:ext uri="{FF2B5EF4-FFF2-40B4-BE49-F238E27FC236}">
-                <a16:creationId xmlns:a16="http://schemas.microsoft.com/office/drawing/2014/main" id="{ED3595E4-15CB-4995-0BB6-97557A0B910F}"/>
+                <a16:creationId xmlns:a16="http://schemas.microsoft.com/office/drawing/2014/main" id="{18B3A820-03C1-70B1-7BF9-000AC6F1805E}"/>
               </a:ext>
             </a:extLst>
           </p:cNvPr>
@@ -6380,7 +6380,7 @@
           <p:cNvPr id="8" name="TextBox 7">
             <a:extLst>
               <a:ext uri="{FF2B5EF4-FFF2-40B4-BE49-F238E27FC236}">
-                <a16:creationId xmlns:a16="http://schemas.microsoft.com/office/drawing/2014/main" id="{C1A9298D-B851-8997-9CBB-48A9E5B34BA2}"/>
+                <a16:creationId xmlns:a16="http://schemas.microsoft.com/office/drawing/2014/main" id="{D9D7201A-92E5-734F-AF82-B7F2D2DCBD1A}"/>
               </a:ext>
             </a:extLst>
           </p:cNvPr>
@@ -6430,7 +6430,7 @@
           <p:cNvPr id="9" name="TextBox 8">
             <a:extLst>
               <a:ext uri="{FF2B5EF4-FFF2-40B4-BE49-F238E27FC236}">
-                <a16:creationId xmlns:a16="http://schemas.microsoft.com/office/drawing/2014/main" id="{D9168323-74F7-7C43-A180-8B4A250D56AC}"/>
+                <a16:creationId xmlns:a16="http://schemas.microsoft.com/office/drawing/2014/main" id="{4D62D02B-D88D-55D7-11E9-80D366C07E13}"/>
               </a:ext>
             </a:extLst>
           </p:cNvPr>
@@ -6483,7 +6483,7 @@
           <p:cNvPr id="10" name="Rectangle: Rounded Corners 9">
             <a:extLst>
               <a:ext uri="{FF2B5EF4-FFF2-40B4-BE49-F238E27FC236}">
-                <a16:creationId xmlns:a16="http://schemas.microsoft.com/office/drawing/2014/main" id="{3FB72638-877B-416E-46FC-30B20A57B11E}"/>
+                <a16:creationId xmlns:a16="http://schemas.microsoft.com/office/drawing/2014/main" id="{4ECBDE1A-2DBA-E62B-A1FF-9EAC245C729B}"/>
               </a:ext>
             </a:extLst>
           </p:cNvPr>
@@ -6537,7 +6537,7 @@
           <p:cNvPr id="11" name="TextBox 10">
             <a:extLst>
               <a:ext uri="{FF2B5EF4-FFF2-40B4-BE49-F238E27FC236}">
-                <a16:creationId xmlns:a16="http://schemas.microsoft.com/office/drawing/2014/main" id="{A38CF16A-7402-D894-E4CA-EEE10CBF2C65}"/>
+                <a16:creationId xmlns:a16="http://schemas.microsoft.com/office/drawing/2014/main" id="{2D6278D0-6850-02B1-B801-BE2DD285A070}"/>
               </a:ext>
             </a:extLst>
           </p:cNvPr>
@@ -6587,7 +6587,7 @@
           <p:cNvPr id="12" name="TextBox 11">
             <a:extLst>
               <a:ext uri="{FF2B5EF4-FFF2-40B4-BE49-F238E27FC236}">
-                <a16:creationId xmlns:a16="http://schemas.microsoft.com/office/drawing/2014/main" id="{9DC8557F-7F23-1148-B8CB-BF088FB0D825}"/>
+                <a16:creationId xmlns:a16="http://schemas.microsoft.com/office/drawing/2014/main" id="{9D2D59D7-F498-6528-91A2-14BE820431DB}"/>
               </a:ext>
             </a:extLst>
           </p:cNvPr>
@@ -6692,7 +6692,7 @@
     </p:spTree>
     <p:extLst>
       <p:ext uri="{BB962C8B-B14F-4D97-AF65-F5344CB8AC3E}">
-        <p14:creationId xmlns:p14="http://schemas.microsoft.com/office/powerpoint/2010/main" val="2273652575"/>
+        <p14:creationId xmlns:p14="http://schemas.microsoft.com/office/powerpoint/2010/main" val="243491674"/>
       </p:ext>
     </p:extLst>
   </p:cSld>
@@ -6724,7 +6724,7 @@
           <p:cNvPr id="2" name="Rectangle 1">
             <a:extLst>
               <a:ext uri="{FF2B5EF4-FFF2-40B4-BE49-F238E27FC236}">
-                <a16:creationId xmlns:a16="http://schemas.microsoft.com/office/drawing/2014/main" id="{7F083444-70A6-6130-051A-8EB7B8CCEF13}"/>
+                <a16:creationId xmlns:a16="http://schemas.microsoft.com/office/drawing/2014/main" id="{A364716E-4376-0D53-0813-8E735E8B90A1}"/>
               </a:ext>
             </a:extLst>
           </p:cNvPr>
@@ -6792,7 +6792,7 @@
           <p:cNvPr id="3" name="Rectangle 2">
             <a:extLst>
               <a:ext uri="{FF2B5EF4-FFF2-40B4-BE49-F238E27FC236}">
-                <a16:creationId xmlns:a16="http://schemas.microsoft.com/office/drawing/2014/main" id="{FC92774D-7A71-DE23-E8EB-1D24DDA8A7DA}"/>
+                <a16:creationId xmlns:a16="http://schemas.microsoft.com/office/drawing/2014/main" id="{DFD3DF20-3BE2-1DCA-B27D-409607C0489D}"/>
               </a:ext>
             </a:extLst>
           </p:cNvPr>
@@ -6860,7 +6860,7 @@
           <p:cNvPr id="4" name="TextBox 3">
             <a:extLst>
               <a:ext uri="{FF2B5EF4-FFF2-40B4-BE49-F238E27FC236}">
-                <a16:creationId xmlns:a16="http://schemas.microsoft.com/office/drawing/2014/main" id="{7194073C-8F63-E4A6-2D05-31044D14B1C8}"/>
+                <a16:creationId xmlns:a16="http://schemas.microsoft.com/office/drawing/2014/main" id="{1F2ABB06-AE3D-3B1A-63CF-5A1CA51325CE}"/>
               </a:ext>
             </a:extLst>
           </p:cNvPr>
@@ -6928,7 +6928,7 @@
           <p:cNvPr id="5" name="TextBox 4">
             <a:extLst>
               <a:ext uri="{FF2B5EF4-FFF2-40B4-BE49-F238E27FC236}">
-                <a16:creationId xmlns:a16="http://schemas.microsoft.com/office/drawing/2014/main" id="{12270770-6917-E99D-D212-DB158385706A}"/>
+                <a16:creationId xmlns:a16="http://schemas.microsoft.com/office/drawing/2014/main" id="{B6014D2F-AD07-6CE2-2F70-FEB37E1FE648}"/>
               </a:ext>
             </a:extLst>
           </p:cNvPr>
@@ -6975,7 +6975,7 @@
           <p:cNvPr id="6" name="TextBox 5">
             <a:extLst>
               <a:ext uri="{FF2B5EF4-FFF2-40B4-BE49-F238E27FC236}">
-                <a16:creationId xmlns:a16="http://schemas.microsoft.com/office/drawing/2014/main" id="{5D0E175F-4C7D-9BC2-05B5-CD47D8C48D4A}"/>
+                <a16:creationId xmlns:a16="http://schemas.microsoft.com/office/drawing/2014/main" id="{F04E40F0-2D69-3C47-9138-9522E4454689}"/>
               </a:ext>
             </a:extLst>
           </p:cNvPr>
@@ -7015,7 +7015,7 @@
           <p:cNvPr id="7" name="Rectangle: Rounded Corners 6">
             <a:extLst>
               <a:ext uri="{FF2B5EF4-FFF2-40B4-BE49-F238E27FC236}">
-                <a16:creationId xmlns:a16="http://schemas.microsoft.com/office/drawing/2014/main" id="{DAA0EF33-B7C0-BD46-9095-C7C4D51EFD85}"/>
+                <a16:creationId xmlns:a16="http://schemas.microsoft.com/office/drawing/2014/main" id="{F6280556-2AAB-E8D7-78CD-77113A8D0D82}"/>
               </a:ext>
             </a:extLst>
           </p:cNvPr>
@@ -7069,7 +7069,7 @@
           <p:cNvPr id="8" name="TextBox 7">
             <a:extLst>
               <a:ext uri="{FF2B5EF4-FFF2-40B4-BE49-F238E27FC236}">
-                <a16:creationId xmlns:a16="http://schemas.microsoft.com/office/drawing/2014/main" id="{F093EE8B-985A-EE1A-13C3-72D5F824D48D}"/>
+                <a16:creationId xmlns:a16="http://schemas.microsoft.com/office/drawing/2014/main" id="{72A21439-607A-5DF9-D5C2-10CE8F4BAA5C}"/>
               </a:ext>
             </a:extLst>
           </p:cNvPr>
@@ -7116,7 +7116,7 @@
           <p:cNvPr id="9" name="TextBox 8">
             <a:extLst>
               <a:ext uri="{FF2B5EF4-FFF2-40B4-BE49-F238E27FC236}">
-                <a16:creationId xmlns:a16="http://schemas.microsoft.com/office/drawing/2014/main" id="{043A6FE6-5FDD-4835-F46F-AFA784436209}"/>
+                <a16:creationId xmlns:a16="http://schemas.microsoft.com/office/drawing/2014/main" id="{DC4450D8-B7B5-09C6-8CDE-095769425393}"/>
               </a:ext>
             </a:extLst>
           </p:cNvPr>
@@ -7172,7 +7172,7 @@
           <p:cNvPr id="10" name="Rectangle: Rounded Corners 9">
             <a:extLst>
               <a:ext uri="{FF2B5EF4-FFF2-40B4-BE49-F238E27FC236}">
-                <a16:creationId xmlns:a16="http://schemas.microsoft.com/office/drawing/2014/main" id="{140A7383-50B7-A840-85CC-1759FA3B9DD2}"/>
+                <a16:creationId xmlns:a16="http://schemas.microsoft.com/office/drawing/2014/main" id="{1BC0EDA4-E6F4-E54B-AEF6-954F8499C6FD}"/>
               </a:ext>
             </a:extLst>
           </p:cNvPr>
@@ -7226,7 +7226,7 @@
           <p:cNvPr id="11" name="TextBox 10">
             <a:extLst>
               <a:ext uri="{FF2B5EF4-FFF2-40B4-BE49-F238E27FC236}">
-                <a16:creationId xmlns:a16="http://schemas.microsoft.com/office/drawing/2014/main" id="{334679FA-83AA-24BB-03A1-F6178571B905}"/>
+                <a16:creationId xmlns:a16="http://schemas.microsoft.com/office/drawing/2014/main" id="{D0882FA7-0D91-D287-8000-CBD6C6D19FA5}"/>
               </a:ext>
             </a:extLst>
           </p:cNvPr>
@@ -7273,7 +7273,7 @@
           <p:cNvPr id="12" name="TextBox 11">
             <a:extLst>
               <a:ext uri="{FF2B5EF4-FFF2-40B4-BE49-F238E27FC236}">
-                <a16:creationId xmlns:a16="http://schemas.microsoft.com/office/drawing/2014/main" id="{312E89EB-3B86-39D6-0E0B-BE53B3305CFB}"/>
+                <a16:creationId xmlns:a16="http://schemas.microsoft.com/office/drawing/2014/main" id="{D1C1B49B-B013-8BE0-C93A-08A4CD6F503D}"/>
               </a:ext>
             </a:extLst>
           </p:cNvPr>
@@ -7344,7 +7344,7 @@
           <p:cNvPr id="13" name="Rectangle: Rounded Corners 12">
             <a:extLst>
               <a:ext uri="{FF2B5EF4-FFF2-40B4-BE49-F238E27FC236}">
-                <a16:creationId xmlns:a16="http://schemas.microsoft.com/office/drawing/2014/main" id="{DFC0AB95-8D8C-9D4E-77EF-5F1773C2CDDB}"/>
+                <a16:creationId xmlns:a16="http://schemas.microsoft.com/office/drawing/2014/main" id="{A2522FA7-B51F-59D9-ED38-DE09233DB7D4}"/>
               </a:ext>
             </a:extLst>
           </p:cNvPr>
@@ -7398,7 +7398,7 @@
           <p:cNvPr id="14" name="TextBox 13">
             <a:extLst>
               <a:ext uri="{FF2B5EF4-FFF2-40B4-BE49-F238E27FC236}">
-                <a16:creationId xmlns:a16="http://schemas.microsoft.com/office/drawing/2014/main" id="{A5AD8FF4-6B82-28A8-8A78-DE731403B013}"/>
+                <a16:creationId xmlns:a16="http://schemas.microsoft.com/office/drawing/2014/main" id="{909D01A1-B837-45C6-CBDF-818752A78AAE}"/>
               </a:ext>
             </a:extLst>
           </p:cNvPr>
@@ -7445,7 +7445,7 @@
           <p:cNvPr id="15" name="TextBox 14">
             <a:extLst>
               <a:ext uri="{FF2B5EF4-FFF2-40B4-BE49-F238E27FC236}">
-                <a16:creationId xmlns:a16="http://schemas.microsoft.com/office/drawing/2014/main" id="{D264EA1A-2CDF-B4FD-EA83-CA0E9238B9B8}"/>
+                <a16:creationId xmlns:a16="http://schemas.microsoft.com/office/drawing/2014/main" id="{B4848FB8-89A0-7068-83B4-4095087946C7}"/>
               </a:ext>
             </a:extLst>
           </p:cNvPr>
@@ -7499,7 +7499,7 @@
     </p:spTree>
     <p:extLst>
       <p:ext uri="{BB962C8B-B14F-4D97-AF65-F5344CB8AC3E}">
-        <p14:creationId xmlns:p14="http://schemas.microsoft.com/office/powerpoint/2010/main" val="2175133513"/>
+        <p14:creationId xmlns:p14="http://schemas.microsoft.com/office/powerpoint/2010/main" val="2969305958"/>
       </p:ext>
     </p:extLst>
   </p:cSld>
@@ -7531,7 +7531,7 @@
           <p:cNvPr id="2" name="Rectangle 1">
             <a:extLst>
               <a:ext uri="{FF2B5EF4-FFF2-40B4-BE49-F238E27FC236}">
-                <a16:creationId xmlns:a16="http://schemas.microsoft.com/office/drawing/2014/main" id="{E72DDE10-E1D8-264A-885D-EA0296C0060D}"/>
+                <a16:creationId xmlns:a16="http://schemas.microsoft.com/office/drawing/2014/main" id="{05D7DFD5-54CC-0888-C08B-DA098CF921A6}"/>
               </a:ext>
             </a:extLst>
           </p:cNvPr>
@@ -7599,7 +7599,7 @@
           <p:cNvPr id="3" name="Rectangle 2">
             <a:extLst>
               <a:ext uri="{FF2B5EF4-FFF2-40B4-BE49-F238E27FC236}">
-                <a16:creationId xmlns:a16="http://schemas.microsoft.com/office/drawing/2014/main" id="{0E429A41-DC67-C64C-37A1-654B2C3E92EE}"/>
+                <a16:creationId xmlns:a16="http://schemas.microsoft.com/office/drawing/2014/main" id="{F2ECFD47-593D-6667-6B74-A03685E1C14D}"/>
               </a:ext>
             </a:extLst>
           </p:cNvPr>
@@ -7667,7 +7667,7 @@
           <p:cNvPr id="4" name="TextBox 3">
             <a:extLst>
               <a:ext uri="{FF2B5EF4-FFF2-40B4-BE49-F238E27FC236}">
-                <a16:creationId xmlns:a16="http://schemas.microsoft.com/office/drawing/2014/main" id="{DE9A6BF1-E579-F34C-BC88-DDE420D8E894}"/>
+                <a16:creationId xmlns:a16="http://schemas.microsoft.com/office/drawing/2014/main" id="{5B2E2791-27C0-55D2-23E5-88F5B75C9261}"/>
               </a:ext>
             </a:extLst>
           </p:cNvPr>
@@ -7735,7 +7735,7 @@
           <p:cNvPr id="5" name="TextBox 4">
             <a:extLst>
               <a:ext uri="{FF2B5EF4-FFF2-40B4-BE49-F238E27FC236}">
-                <a16:creationId xmlns:a16="http://schemas.microsoft.com/office/drawing/2014/main" id="{CBA68CFE-76E1-6ABC-41BE-233B162D9BEC}"/>
+                <a16:creationId xmlns:a16="http://schemas.microsoft.com/office/drawing/2014/main" id="{A805EC48-85C2-DE30-1868-F90E9391021E}"/>
               </a:ext>
             </a:extLst>
           </p:cNvPr>
@@ -7782,7 +7782,7 @@
           <p:cNvPr id="6" name="TextBox 5">
             <a:extLst>
               <a:ext uri="{FF2B5EF4-FFF2-40B4-BE49-F238E27FC236}">
-                <a16:creationId xmlns:a16="http://schemas.microsoft.com/office/drawing/2014/main" id="{79FD5676-78B7-28C4-B8A0-8543247C81FD}"/>
+                <a16:creationId xmlns:a16="http://schemas.microsoft.com/office/drawing/2014/main" id="{90D650FA-ECD1-DA91-924A-7C1166D0FC33}"/>
               </a:ext>
             </a:extLst>
           </p:cNvPr>
@@ -7822,7 +7822,7 @@
           <p:cNvPr id="7" name="Rectangle: Rounded Corners 6">
             <a:extLst>
               <a:ext uri="{FF2B5EF4-FFF2-40B4-BE49-F238E27FC236}">
-                <a16:creationId xmlns:a16="http://schemas.microsoft.com/office/drawing/2014/main" id="{9E9950B1-BAAF-7713-0D02-980C542DD375}"/>
+                <a16:creationId xmlns:a16="http://schemas.microsoft.com/office/drawing/2014/main" id="{DAC0259C-0476-2AF4-2FD2-753C3AFC9812}"/>
               </a:ext>
             </a:extLst>
           </p:cNvPr>
@@ -7876,7 +7876,7 @@
           <p:cNvPr id="8" name="TextBox 7">
             <a:extLst>
               <a:ext uri="{FF2B5EF4-FFF2-40B4-BE49-F238E27FC236}">
-                <a16:creationId xmlns:a16="http://schemas.microsoft.com/office/drawing/2014/main" id="{FC3AB9D2-2AA2-1EC5-7DBF-6CC414AE7F1B}"/>
+                <a16:creationId xmlns:a16="http://schemas.microsoft.com/office/drawing/2014/main" id="{40322D4A-E734-8306-782E-EB0DCC8CA955}"/>
               </a:ext>
             </a:extLst>
           </p:cNvPr>
@@ -7923,7 +7923,7 @@
           <p:cNvPr id="9" name="TextBox 8">
             <a:extLst>
               <a:ext uri="{FF2B5EF4-FFF2-40B4-BE49-F238E27FC236}">
-                <a16:creationId xmlns:a16="http://schemas.microsoft.com/office/drawing/2014/main" id="{2EF74220-A84F-7A21-C8B2-260EDE72140D}"/>
+                <a16:creationId xmlns:a16="http://schemas.microsoft.com/office/drawing/2014/main" id="{EAA39776-D15F-E104-7C9C-99FD4C7C56E4}"/>
               </a:ext>
             </a:extLst>
           </p:cNvPr>
@@ -8012,7 +8012,7 @@
           <p:cNvPr id="10" name="Rectangle: Rounded Corners 9">
             <a:extLst>
               <a:ext uri="{FF2B5EF4-FFF2-40B4-BE49-F238E27FC236}">
-                <a16:creationId xmlns:a16="http://schemas.microsoft.com/office/drawing/2014/main" id="{2E5CA94E-7597-9F8A-2DE3-A0425EDF2DFA}"/>
+                <a16:creationId xmlns:a16="http://schemas.microsoft.com/office/drawing/2014/main" id="{D7D6DB29-E0B2-1F42-51E2-03215825E3C0}"/>
               </a:ext>
             </a:extLst>
           </p:cNvPr>
@@ -8066,7 +8066,7 @@
           <p:cNvPr id="11" name="TextBox 10">
             <a:extLst>
               <a:ext uri="{FF2B5EF4-FFF2-40B4-BE49-F238E27FC236}">
-                <a16:creationId xmlns:a16="http://schemas.microsoft.com/office/drawing/2014/main" id="{45DF5182-40DF-0979-56F2-53EBEBA8997D}"/>
+                <a16:creationId xmlns:a16="http://schemas.microsoft.com/office/drawing/2014/main" id="{F22F0A57-44EB-2D49-15A4-B8A55B42B5FC}"/>
               </a:ext>
             </a:extLst>
           </p:cNvPr>
@@ -8113,7 +8113,7 @@
           <p:cNvPr id="12" name="TextBox 11">
             <a:extLst>
               <a:ext uri="{FF2B5EF4-FFF2-40B4-BE49-F238E27FC236}">
-                <a16:creationId xmlns:a16="http://schemas.microsoft.com/office/drawing/2014/main" id="{20386E49-E6EC-424F-8A5D-8E4A12882575}"/>
+                <a16:creationId xmlns:a16="http://schemas.microsoft.com/office/drawing/2014/main" id="{1472361F-6BC5-E71C-91C2-2AC36533D03E}"/>
               </a:ext>
             </a:extLst>
           </p:cNvPr>
@@ -8166,7 +8166,7 @@
           <p:cNvPr id="13" name="Rectangle: Rounded Corners 12">
             <a:extLst>
               <a:ext uri="{FF2B5EF4-FFF2-40B4-BE49-F238E27FC236}">
-                <a16:creationId xmlns:a16="http://schemas.microsoft.com/office/drawing/2014/main" id="{125A915D-EC01-5A53-BA67-284554FBB2F7}"/>
+                <a16:creationId xmlns:a16="http://schemas.microsoft.com/office/drawing/2014/main" id="{F6180D0E-D9B5-5CE9-F526-D54A9F9216CD}"/>
               </a:ext>
             </a:extLst>
           </p:cNvPr>
@@ -8220,7 +8220,7 @@
           <p:cNvPr id="14" name="TextBox 13">
             <a:extLst>
               <a:ext uri="{FF2B5EF4-FFF2-40B4-BE49-F238E27FC236}">
-                <a16:creationId xmlns:a16="http://schemas.microsoft.com/office/drawing/2014/main" id="{9D7DDCD0-CA47-9A70-FCB8-445A85C9E240}"/>
+                <a16:creationId xmlns:a16="http://schemas.microsoft.com/office/drawing/2014/main" id="{D91A1DBD-ACF5-67D3-5D25-AA09D0A2EF39}"/>
               </a:ext>
             </a:extLst>
           </p:cNvPr>
@@ -8267,7 +8267,7 @@
           <p:cNvPr id="15" name="TextBox 14">
             <a:extLst>
               <a:ext uri="{FF2B5EF4-FFF2-40B4-BE49-F238E27FC236}">
-                <a16:creationId xmlns:a16="http://schemas.microsoft.com/office/drawing/2014/main" id="{E4281742-80D6-EFC1-1769-192E54E3ADB2}"/>
+                <a16:creationId xmlns:a16="http://schemas.microsoft.com/office/drawing/2014/main" id="{F4DEF545-2537-9882-E72B-C08A3749C600}"/>
               </a:ext>
             </a:extLst>
           </p:cNvPr>
@@ -8338,7 +8338,7 @@
           <p:cNvPr id="16" name="Rectangle: Rounded Corners 15">
             <a:extLst>
               <a:ext uri="{FF2B5EF4-FFF2-40B4-BE49-F238E27FC236}">
-                <a16:creationId xmlns:a16="http://schemas.microsoft.com/office/drawing/2014/main" id="{FCF65493-8549-6E3A-0555-8C438579F25D}"/>
+                <a16:creationId xmlns:a16="http://schemas.microsoft.com/office/drawing/2014/main" id="{4DF8C98A-AA93-051C-81FB-97548605B45A}"/>
               </a:ext>
             </a:extLst>
           </p:cNvPr>
@@ -8392,7 +8392,7 @@
           <p:cNvPr id="17" name="TextBox 16">
             <a:extLst>
               <a:ext uri="{FF2B5EF4-FFF2-40B4-BE49-F238E27FC236}">
-                <a16:creationId xmlns:a16="http://schemas.microsoft.com/office/drawing/2014/main" id="{23341E83-6438-3684-9F93-7AACBBFDB2F5}"/>
+                <a16:creationId xmlns:a16="http://schemas.microsoft.com/office/drawing/2014/main" id="{B8873DC9-CA3F-20F2-AE88-C22AFC1FF969}"/>
               </a:ext>
             </a:extLst>
           </p:cNvPr>
@@ -8433,7 +8433,7 @@
           <p:cNvPr id="18" name="TextBox 17">
             <a:extLst>
               <a:ext uri="{FF2B5EF4-FFF2-40B4-BE49-F238E27FC236}">
-                <a16:creationId xmlns:a16="http://schemas.microsoft.com/office/drawing/2014/main" id="{6662CD8F-0FB4-1835-D869-09831FA65143}"/>
+                <a16:creationId xmlns:a16="http://schemas.microsoft.com/office/drawing/2014/main" id="{8EECDDE0-E7C7-4DC6-5A3E-B6163FF1BF3D}"/>
               </a:ext>
             </a:extLst>
           </p:cNvPr>
@@ -8484,7 +8484,7 @@
     </p:spTree>
     <p:extLst>
       <p:ext uri="{BB962C8B-B14F-4D97-AF65-F5344CB8AC3E}">
-        <p14:creationId xmlns:p14="http://schemas.microsoft.com/office/powerpoint/2010/main" val="159712778"/>
+        <p14:creationId xmlns:p14="http://schemas.microsoft.com/office/powerpoint/2010/main" val="624431039"/>
       </p:ext>
     </p:extLst>
   </p:cSld>
@@ -8516,7 +8516,7 @@
           <p:cNvPr id="2" name="Rectangle 1">
             <a:extLst>
               <a:ext uri="{FF2B5EF4-FFF2-40B4-BE49-F238E27FC236}">
-                <a16:creationId xmlns:a16="http://schemas.microsoft.com/office/drawing/2014/main" id="{BAE199E5-43B4-F307-4658-19BCDD3976DA}"/>
+                <a16:creationId xmlns:a16="http://schemas.microsoft.com/office/drawing/2014/main" id="{F0C57B8E-B1F1-7990-EFDA-BE06F35C8B2A}"/>
               </a:ext>
             </a:extLst>
           </p:cNvPr>
@@ -8584,7 +8584,7 @@
           <p:cNvPr id="3" name="Rectangle 2">
             <a:extLst>
               <a:ext uri="{FF2B5EF4-FFF2-40B4-BE49-F238E27FC236}">
-                <a16:creationId xmlns:a16="http://schemas.microsoft.com/office/drawing/2014/main" id="{1403555D-27CE-05A1-B22B-AAE095CACF7F}"/>
+                <a16:creationId xmlns:a16="http://schemas.microsoft.com/office/drawing/2014/main" id="{EC656F08-F9D5-CD7E-1434-74FC77026CB6}"/>
               </a:ext>
             </a:extLst>
           </p:cNvPr>
@@ -8652,7 +8652,7 @@
           <p:cNvPr id="4" name="TextBox 3">
             <a:extLst>
               <a:ext uri="{FF2B5EF4-FFF2-40B4-BE49-F238E27FC236}">
-                <a16:creationId xmlns:a16="http://schemas.microsoft.com/office/drawing/2014/main" id="{65BAC43A-0260-F78F-F437-C1665EC2C754}"/>
+                <a16:creationId xmlns:a16="http://schemas.microsoft.com/office/drawing/2014/main" id="{2E522827-74EB-73ED-66D8-7B006AA7364F}"/>
               </a:ext>
             </a:extLst>
           </p:cNvPr>
@@ -8720,7 +8720,7 @@
           <p:cNvPr id="5" name="TextBox 4">
             <a:extLst>
               <a:ext uri="{FF2B5EF4-FFF2-40B4-BE49-F238E27FC236}">
-                <a16:creationId xmlns:a16="http://schemas.microsoft.com/office/drawing/2014/main" id="{D3EEE71D-79EC-E152-FA22-0FB96D337AFA}"/>
+                <a16:creationId xmlns:a16="http://schemas.microsoft.com/office/drawing/2014/main" id="{3B574171-3619-12AD-98C2-DFE7B7CFCB4E}"/>
               </a:ext>
             </a:extLst>
           </p:cNvPr>
@@ -8785,7 +8785,7 @@
           <p:cNvPr id="6" name="TextBox 5">
             <a:extLst>
               <a:ext uri="{FF2B5EF4-FFF2-40B4-BE49-F238E27FC236}">
-                <a16:creationId xmlns:a16="http://schemas.microsoft.com/office/drawing/2014/main" id="{A51B3291-B6BA-3472-3235-596916832D6F}"/>
+                <a16:creationId xmlns:a16="http://schemas.microsoft.com/office/drawing/2014/main" id="{C5BF1C44-788E-59F4-379C-889C490A4C73}"/>
               </a:ext>
             </a:extLst>
           </p:cNvPr>
@@ -8825,7 +8825,7 @@
           <p:cNvPr id="7" name="Rectangle: Rounded Corners 6">
             <a:extLst>
               <a:ext uri="{FF2B5EF4-FFF2-40B4-BE49-F238E27FC236}">
-                <a16:creationId xmlns:a16="http://schemas.microsoft.com/office/drawing/2014/main" id="{DF33D420-40CA-47BB-1851-C0F5AB71FC67}"/>
+                <a16:creationId xmlns:a16="http://schemas.microsoft.com/office/drawing/2014/main" id="{B8FB6365-3E66-BB20-58EA-D30BA7BC41BC}"/>
               </a:ext>
             </a:extLst>
           </p:cNvPr>
@@ -8879,7 +8879,7 @@
           <p:cNvPr id="8" name="TextBox 7">
             <a:extLst>
               <a:ext uri="{FF2B5EF4-FFF2-40B4-BE49-F238E27FC236}">
-                <a16:creationId xmlns:a16="http://schemas.microsoft.com/office/drawing/2014/main" id="{0B9C3F4E-CA67-3B1B-89E6-EFAD5008B706}"/>
+                <a16:creationId xmlns:a16="http://schemas.microsoft.com/office/drawing/2014/main" id="{E48BA100-0B9E-5180-501C-18FABF63FA9F}"/>
               </a:ext>
             </a:extLst>
           </p:cNvPr>
@@ -8926,7 +8926,7 @@
           <p:cNvPr id="9" name="TextBox 8">
             <a:extLst>
               <a:ext uri="{FF2B5EF4-FFF2-40B4-BE49-F238E27FC236}">
-                <a16:creationId xmlns:a16="http://schemas.microsoft.com/office/drawing/2014/main" id="{702ED77E-60B3-E7B7-EE4C-0AC63150CB4C}"/>
+                <a16:creationId xmlns:a16="http://schemas.microsoft.com/office/drawing/2014/main" id="{9328ADDB-BECE-C3F6-48EA-E72332F114EB}"/>
               </a:ext>
             </a:extLst>
           </p:cNvPr>
@@ -9001,7 +9001,7 @@
           <p:cNvPr id="10" name="Rectangle: Rounded Corners 9">
             <a:extLst>
               <a:ext uri="{FF2B5EF4-FFF2-40B4-BE49-F238E27FC236}">
-                <a16:creationId xmlns:a16="http://schemas.microsoft.com/office/drawing/2014/main" id="{9EE4764C-20E6-8DD5-47B0-0897DE9408E9}"/>
+                <a16:creationId xmlns:a16="http://schemas.microsoft.com/office/drawing/2014/main" id="{D73FD644-6C80-1A4E-9B01-B4596A43D043}"/>
               </a:ext>
             </a:extLst>
           </p:cNvPr>
@@ -9055,7 +9055,7 @@
           <p:cNvPr id="11" name="TextBox 10">
             <a:extLst>
               <a:ext uri="{FF2B5EF4-FFF2-40B4-BE49-F238E27FC236}">
-                <a16:creationId xmlns:a16="http://schemas.microsoft.com/office/drawing/2014/main" id="{E67E2A5A-6AD4-A6CF-BB86-D85458F5B9C8}"/>
+                <a16:creationId xmlns:a16="http://schemas.microsoft.com/office/drawing/2014/main" id="{E34E8AA9-B251-EAF2-2AAA-A2472719F5B2}"/>
               </a:ext>
             </a:extLst>
           </p:cNvPr>
@@ -9120,7 +9120,7 @@
           <p:cNvPr id="12" name="TextBox 11">
             <a:extLst>
               <a:ext uri="{FF2B5EF4-FFF2-40B4-BE49-F238E27FC236}">
-                <a16:creationId xmlns:a16="http://schemas.microsoft.com/office/drawing/2014/main" id="{1054C88B-E04E-F473-8EC5-34CCE923DB19}"/>
+                <a16:creationId xmlns:a16="http://schemas.microsoft.com/office/drawing/2014/main" id="{C100E462-6E86-4D70-A32F-69AE167FF80F}"/>
               </a:ext>
             </a:extLst>
           </p:cNvPr>
@@ -9174,7 +9174,7 @@
           <p:cNvPr id="13" name="Rectangle: Rounded Corners 12">
             <a:extLst>
               <a:ext uri="{FF2B5EF4-FFF2-40B4-BE49-F238E27FC236}">
-                <a16:creationId xmlns:a16="http://schemas.microsoft.com/office/drawing/2014/main" id="{8B602AE0-15FC-0FAB-4861-7085A43E56FA}"/>
+                <a16:creationId xmlns:a16="http://schemas.microsoft.com/office/drawing/2014/main" id="{943C5DD8-3C6C-5132-9069-73DBCC75F013}"/>
               </a:ext>
             </a:extLst>
           </p:cNvPr>
@@ -9228,7 +9228,7 @@
           <p:cNvPr id="14" name="TextBox 13">
             <a:extLst>
               <a:ext uri="{FF2B5EF4-FFF2-40B4-BE49-F238E27FC236}">
-                <a16:creationId xmlns:a16="http://schemas.microsoft.com/office/drawing/2014/main" id="{646D1E09-9C2B-4B09-5DE1-3D5089E36F09}"/>
+                <a16:creationId xmlns:a16="http://schemas.microsoft.com/office/drawing/2014/main" id="{0A3928A8-00AB-03C5-9167-0DB1E54A7446}"/>
               </a:ext>
             </a:extLst>
           </p:cNvPr>
@@ -9293,7 +9293,7 @@
           <p:cNvPr id="15" name="TextBox 14">
             <a:extLst>
               <a:ext uri="{FF2B5EF4-FFF2-40B4-BE49-F238E27FC236}">
-                <a16:creationId xmlns:a16="http://schemas.microsoft.com/office/drawing/2014/main" id="{34442847-C8E3-D83F-3E9A-E50B1052755D}"/>
+                <a16:creationId xmlns:a16="http://schemas.microsoft.com/office/drawing/2014/main" id="{261134C3-86B7-3548-9256-635D9147E780}"/>
               </a:ext>
             </a:extLst>
           </p:cNvPr>
@@ -9345,7 +9345,7 @@
     </p:spTree>
     <p:extLst>
       <p:ext uri="{BB962C8B-B14F-4D97-AF65-F5344CB8AC3E}">
-        <p14:creationId xmlns:p14="http://schemas.microsoft.com/office/powerpoint/2010/main" val="3216487002"/>
+        <p14:creationId xmlns:p14="http://schemas.microsoft.com/office/powerpoint/2010/main" val="3566509467"/>
       </p:ext>
     </p:extLst>
   </p:cSld>
@@ -9377,7 +9377,7 @@
           <p:cNvPr id="2" name="Rectangle 1">
             <a:extLst>
               <a:ext uri="{FF2B5EF4-FFF2-40B4-BE49-F238E27FC236}">
-                <a16:creationId xmlns:a16="http://schemas.microsoft.com/office/drawing/2014/main" id="{68792742-321B-2B9E-FCA3-660515550CAA}"/>
+                <a16:creationId xmlns:a16="http://schemas.microsoft.com/office/drawing/2014/main" id="{AD17BE1C-BD91-DC26-A77F-580AD40C4A51}"/>
               </a:ext>
             </a:extLst>
           </p:cNvPr>
@@ -9445,7 +9445,7 @@
           <p:cNvPr id="3" name="Rectangle 2">
             <a:extLst>
               <a:ext uri="{FF2B5EF4-FFF2-40B4-BE49-F238E27FC236}">
-                <a16:creationId xmlns:a16="http://schemas.microsoft.com/office/drawing/2014/main" id="{5F6C882F-8028-470A-5405-B4867BD137E1}"/>
+                <a16:creationId xmlns:a16="http://schemas.microsoft.com/office/drawing/2014/main" id="{7A3151D0-5ED1-1EA6-964E-60B297B3D157}"/>
               </a:ext>
             </a:extLst>
           </p:cNvPr>
@@ -9513,7 +9513,7 @@
           <p:cNvPr id="4" name="TextBox 3">
             <a:extLst>
               <a:ext uri="{FF2B5EF4-FFF2-40B4-BE49-F238E27FC236}">
-                <a16:creationId xmlns:a16="http://schemas.microsoft.com/office/drawing/2014/main" id="{64BB5F08-D21D-ED14-98BA-5614BC136B07}"/>
+                <a16:creationId xmlns:a16="http://schemas.microsoft.com/office/drawing/2014/main" id="{B56C2391-4C40-54AE-5AA7-3B0BA4FC6EED}"/>
               </a:ext>
             </a:extLst>
           </p:cNvPr>
@@ -9581,7 +9581,7 @@
           <p:cNvPr id="5" name="TextBox 4">
             <a:extLst>
               <a:ext uri="{FF2B5EF4-FFF2-40B4-BE49-F238E27FC236}">
-                <a16:creationId xmlns:a16="http://schemas.microsoft.com/office/drawing/2014/main" id="{1F9B1CF9-9819-E351-EDE9-8CFC89CC76A8}"/>
+                <a16:creationId xmlns:a16="http://schemas.microsoft.com/office/drawing/2014/main" id="{E39C5A10-FF9D-793B-EF2B-9CF2B429A28B}"/>
               </a:ext>
             </a:extLst>
           </p:cNvPr>
@@ -9646,7 +9646,7 @@
           <p:cNvPr id="6" name="TextBox 5">
             <a:extLst>
               <a:ext uri="{FF2B5EF4-FFF2-40B4-BE49-F238E27FC236}">
-                <a16:creationId xmlns:a16="http://schemas.microsoft.com/office/drawing/2014/main" id="{13E15186-D0D2-4C19-5068-BDFEEFD1BC10}"/>
+                <a16:creationId xmlns:a16="http://schemas.microsoft.com/office/drawing/2014/main" id="{F957D00B-FB1C-5759-1BA0-C152A5A2EB3A}"/>
               </a:ext>
             </a:extLst>
           </p:cNvPr>
@@ -9686,7 +9686,7 @@
           <p:cNvPr id="7" name="Rectangle: Rounded Corners 6">
             <a:extLst>
               <a:ext uri="{FF2B5EF4-FFF2-40B4-BE49-F238E27FC236}">
-                <a16:creationId xmlns:a16="http://schemas.microsoft.com/office/drawing/2014/main" id="{C8BDC9E8-A126-7061-31F9-5055DA3B5E18}"/>
+                <a16:creationId xmlns:a16="http://schemas.microsoft.com/office/drawing/2014/main" id="{B772E0B7-4C1D-BD45-5130-85DAA483D50A}"/>
               </a:ext>
             </a:extLst>
           </p:cNvPr>
@@ -9740,7 +9740,7 @@
           <p:cNvPr id="8" name="TextBox 7">
             <a:extLst>
               <a:ext uri="{FF2B5EF4-FFF2-40B4-BE49-F238E27FC236}">
-                <a16:creationId xmlns:a16="http://schemas.microsoft.com/office/drawing/2014/main" id="{C0C8A66D-101D-AF7E-0671-EECE91BEFEF2}"/>
+                <a16:creationId xmlns:a16="http://schemas.microsoft.com/office/drawing/2014/main" id="{333708DC-DC59-FD6F-4D27-20C9F2D42A64}"/>
               </a:ext>
             </a:extLst>
           </p:cNvPr>
@@ -9796,7 +9796,7 @@
           <p:cNvPr id="9" name="TextBox 8">
             <a:extLst>
               <a:ext uri="{FF2B5EF4-FFF2-40B4-BE49-F238E27FC236}">
-                <a16:creationId xmlns:a16="http://schemas.microsoft.com/office/drawing/2014/main" id="{FF880B09-6D53-11B8-B099-5197321437FC}"/>
+                <a16:creationId xmlns:a16="http://schemas.microsoft.com/office/drawing/2014/main" id="{A112AE02-E666-258E-763B-8CF9422E4C60}"/>
               </a:ext>
             </a:extLst>
           </p:cNvPr>
@@ -9849,7 +9849,7 @@
           <p:cNvPr id="10" name="Rectangle: Rounded Corners 9">
             <a:extLst>
               <a:ext uri="{FF2B5EF4-FFF2-40B4-BE49-F238E27FC236}">
-                <a16:creationId xmlns:a16="http://schemas.microsoft.com/office/drawing/2014/main" id="{F21E3D25-4FE7-C1F0-E004-5B2DF4B00EC0}"/>
+                <a16:creationId xmlns:a16="http://schemas.microsoft.com/office/drawing/2014/main" id="{E911313E-B509-9F3C-6647-C6C9EFDC7883}"/>
               </a:ext>
             </a:extLst>
           </p:cNvPr>
@@ -9903,7 +9903,7 @@
           <p:cNvPr id="11" name="TextBox 10">
             <a:extLst>
               <a:ext uri="{FF2B5EF4-FFF2-40B4-BE49-F238E27FC236}">
-                <a16:creationId xmlns:a16="http://schemas.microsoft.com/office/drawing/2014/main" id="{94062667-F286-E3FC-74BC-1E044C094DFC}"/>
+                <a16:creationId xmlns:a16="http://schemas.microsoft.com/office/drawing/2014/main" id="{61922F95-0336-65A1-2A69-7882D4F20D8C}"/>
               </a:ext>
             </a:extLst>
           </p:cNvPr>
@@ -9959,7 +9959,7 @@
           <p:cNvPr id="12" name="TextBox 11">
             <a:extLst>
               <a:ext uri="{FF2B5EF4-FFF2-40B4-BE49-F238E27FC236}">
-                <a16:creationId xmlns:a16="http://schemas.microsoft.com/office/drawing/2014/main" id="{54A5A0C1-6D94-E828-49F9-1D435DC78791}"/>
+                <a16:creationId xmlns:a16="http://schemas.microsoft.com/office/drawing/2014/main" id="{CC0E78FF-6E13-50D6-E6B9-0E1293863EE5}"/>
               </a:ext>
             </a:extLst>
           </p:cNvPr>
@@ -10012,7 +10012,7 @@
           <p:cNvPr id="13" name="Rectangle: Rounded Corners 12">
             <a:extLst>
               <a:ext uri="{FF2B5EF4-FFF2-40B4-BE49-F238E27FC236}">
-                <a16:creationId xmlns:a16="http://schemas.microsoft.com/office/drawing/2014/main" id="{0F0DE131-9544-CFC5-7F5D-02B9467FB944}"/>
+                <a16:creationId xmlns:a16="http://schemas.microsoft.com/office/drawing/2014/main" id="{ED34E429-EAB0-E7D4-812C-6CA1237A0270}"/>
               </a:ext>
             </a:extLst>
           </p:cNvPr>
@@ -10066,7 +10066,7 @@
           <p:cNvPr id="14" name="TextBox 13">
             <a:extLst>
               <a:ext uri="{FF2B5EF4-FFF2-40B4-BE49-F238E27FC236}">
-                <a16:creationId xmlns:a16="http://schemas.microsoft.com/office/drawing/2014/main" id="{27BB52D1-F8EC-6F81-D017-73A0281C5CB2}"/>
+                <a16:creationId xmlns:a16="http://schemas.microsoft.com/office/drawing/2014/main" id="{66A6B625-B885-C871-B69B-B576A04E0E27}"/>
               </a:ext>
             </a:extLst>
           </p:cNvPr>
@@ -10122,7 +10122,7 @@
           <p:cNvPr id="15" name="TextBox 14">
             <a:extLst>
               <a:ext uri="{FF2B5EF4-FFF2-40B4-BE49-F238E27FC236}">
-                <a16:creationId xmlns:a16="http://schemas.microsoft.com/office/drawing/2014/main" id="{F9702F8D-D0CB-88A5-0129-4193AB5AF965}"/>
+                <a16:creationId xmlns:a16="http://schemas.microsoft.com/office/drawing/2014/main" id="{DE073064-C545-B3C7-4AAC-1E0813880529}"/>
               </a:ext>
             </a:extLst>
           </p:cNvPr>
@@ -10193,7 +10193,7 @@
           <p:cNvPr id="16" name="Rectangle: Rounded Corners 15">
             <a:extLst>
               <a:ext uri="{FF2B5EF4-FFF2-40B4-BE49-F238E27FC236}">
-                <a16:creationId xmlns:a16="http://schemas.microsoft.com/office/drawing/2014/main" id="{C333009C-884A-9156-5E87-BA6A0A6CAE30}"/>
+                <a16:creationId xmlns:a16="http://schemas.microsoft.com/office/drawing/2014/main" id="{4122410C-BEAF-93C4-DCB6-F8259452A1B9}"/>
               </a:ext>
             </a:extLst>
           </p:cNvPr>
@@ -10247,7 +10247,7 @@
           <p:cNvPr id="17" name="TextBox 16">
             <a:extLst>
               <a:ext uri="{FF2B5EF4-FFF2-40B4-BE49-F238E27FC236}">
-                <a16:creationId xmlns:a16="http://schemas.microsoft.com/office/drawing/2014/main" id="{2276AAFB-2AF1-35DE-00CD-101A15D277AB}"/>
+                <a16:creationId xmlns:a16="http://schemas.microsoft.com/office/drawing/2014/main" id="{2806C247-CCBD-1B14-A7E4-582B575602D2}"/>
               </a:ext>
             </a:extLst>
           </p:cNvPr>
@@ -10303,7 +10303,7 @@
           <p:cNvPr id="18" name="TextBox 17">
             <a:extLst>
               <a:ext uri="{FF2B5EF4-FFF2-40B4-BE49-F238E27FC236}">
-                <a16:creationId xmlns:a16="http://schemas.microsoft.com/office/drawing/2014/main" id="{771CF477-76B4-BD22-2BBA-788081A3A57C}"/>
+                <a16:creationId xmlns:a16="http://schemas.microsoft.com/office/drawing/2014/main" id="{79CD78E7-00BA-1EF8-066F-7B0682C5327B}"/>
               </a:ext>
             </a:extLst>
           </p:cNvPr>
@@ -10390,7 +10390,7 @@
     </p:spTree>
     <p:extLst>
       <p:ext uri="{BB962C8B-B14F-4D97-AF65-F5344CB8AC3E}">
-        <p14:creationId xmlns:p14="http://schemas.microsoft.com/office/powerpoint/2010/main" val="2761988931"/>
+        <p14:creationId xmlns:p14="http://schemas.microsoft.com/office/powerpoint/2010/main" val="4040478343"/>
       </p:ext>
     </p:extLst>
   </p:cSld>
@@ -10422,7 +10422,7 @@
           <p:cNvPr id="2" name="Rectangle 1">
             <a:extLst>
               <a:ext uri="{FF2B5EF4-FFF2-40B4-BE49-F238E27FC236}">
-                <a16:creationId xmlns:a16="http://schemas.microsoft.com/office/drawing/2014/main" id="{82BEDEB9-5D9D-3E8C-F6A5-3AB26CE45A5A}"/>
+                <a16:creationId xmlns:a16="http://schemas.microsoft.com/office/drawing/2014/main" id="{DB8F4BF9-FF76-5BA4-4DED-3CEB5F074663}"/>
               </a:ext>
             </a:extLst>
           </p:cNvPr>
@@ -10490,7 +10490,7 @@
           <p:cNvPr id="3" name="Rectangle 2">
             <a:extLst>
               <a:ext uri="{FF2B5EF4-FFF2-40B4-BE49-F238E27FC236}">
-                <a16:creationId xmlns:a16="http://schemas.microsoft.com/office/drawing/2014/main" id="{D454A13B-B4D1-C784-E800-494CEB287EFD}"/>
+                <a16:creationId xmlns:a16="http://schemas.microsoft.com/office/drawing/2014/main" id="{881C9684-19D8-FE53-AF70-D5B3F6B59AE4}"/>
               </a:ext>
             </a:extLst>
           </p:cNvPr>
@@ -10558,7 +10558,7 @@
           <p:cNvPr id="4" name="TextBox 3">
             <a:extLst>
               <a:ext uri="{FF2B5EF4-FFF2-40B4-BE49-F238E27FC236}">
-                <a16:creationId xmlns:a16="http://schemas.microsoft.com/office/drawing/2014/main" id="{91A6F448-82B7-9EA4-B817-E85DDB47C0D0}"/>
+                <a16:creationId xmlns:a16="http://schemas.microsoft.com/office/drawing/2014/main" id="{B5063BC1-8864-1360-052A-ADC4C84A81CA}"/>
               </a:ext>
             </a:extLst>
           </p:cNvPr>
@@ -10626,7 +10626,7 @@
           <p:cNvPr id="5" name="TextBox 4">
             <a:extLst>
               <a:ext uri="{FF2B5EF4-FFF2-40B4-BE49-F238E27FC236}">
-                <a16:creationId xmlns:a16="http://schemas.microsoft.com/office/drawing/2014/main" id="{04AFBFB4-2F37-49A7-CA1F-012A45786690}"/>
+                <a16:creationId xmlns:a16="http://schemas.microsoft.com/office/drawing/2014/main" id="{AF3389DF-429E-7CF5-D559-594B076DA652}"/>
               </a:ext>
             </a:extLst>
           </p:cNvPr>
@@ -10673,7 +10673,7 @@
           <p:cNvPr id="6" name="TextBox 5">
             <a:extLst>
               <a:ext uri="{FF2B5EF4-FFF2-40B4-BE49-F238E27FC236}">
-                <a16:creationId xmlns:a16="http://schemas.microsoft.com/office/drawing/2014/main" id="{76A58756-0368-E546-94B2-C4026B446113}"/>
+                <a16:creationId xmlns:a16="http://schemas.microsoft.com/office/drawing/2014/main" id="{F66C7B6B-9CE2-9983-8DD1-9281D46024D2}"/>
               </a:ext>
             </a:extLst>
           </p:cNvPr>
@@ -10713,7 +10713,7 @@
           <p:cNvPr id="7" name="Rectangle: Rounded Corners 6">
             <a:extLst>
               <a:ext uri="{FF2B5EF4-FFF2-40B4-BE49-F238E27FC236}">
-                <a16:creationId xmlns:a16="http://schemas.microsoft.com/office/drawing/2014/main" id="{BFC01B10-0AC2-D5BA-D2C9-94431A37432B}"/>
+                <a16:creationId xmlns:a16="http://schemas.microsoft.com/office/drawing/2014/main" id="{38EB1FCE-B692-E80B-09ED-F9DC6046D04A}"/>
               </a:ext>
             </a:extLst>
           </p:cNvPr>
@@ -10767,7 +10767,7 @@
           <p:cNvPr id="8" name="TextBox 7">
             <a:extLst>
               <a:ext uri="{FF2B5EF4-FFF2-40B4-BE49-F238E27FC236}">
-                <a16:creationId xmlns:a16="http://schemas.microsoft.com/office/drawing/2014/main" id="{A8EF6873-4E41-1A53-3F86-EB3F784E9EEB}"/>
+                <a16:creationId xmlns:a16="http://schemas.microsoft.com/office/drawing/2014/main" id="{2B893CA2-318A-E84F-8DA2-DFC9C1EBAF25}"/>
               </a:ext>
             </a:extLst>
           </p:cNvPr>
@@ -10814,7 +10814,7 @@
           <p:cNvPr id="9" name="TextBox 8">
             <a:extLst>
               <a:ext uri="{FF2B5EF4-FFF2-40B4-BE49-F238E27FC236}">
-                <a16:creationId xmlns:a16="http://schemas.microsoft.com/office/drawing/2014/main" id="{329C07E0-7C8D-813A-E29A-F28D44E32BD6}"/>
+                <a16:creationId xmlns:a16="http://schemas.microsoft.com/office/drawing/2014/main" id="{02256E6E-50C4-8E91-EBAD-C11E22B8DA0B}"/>
               </a:ext>
             </a:extLst>
           </p:cNvPr>
@@ -10868,7 +10868,7 @@
           <p:cNvPr id="10" name="Rectangle: Rounded Corners 9">
             <a:extLst>
               <a:ext uri="{FF2B5EF4-FFF2-40B4-BE49-F238E27FC236}">
-                <a16:creationId xmlns:a16="http://schemas.microsoft.com/office/drawing/2014/main" id="{BDE88B44-1F72-0A9B-AE8C-F752A1C4E184}"/>
+                <a16:creationId xmlns:a16="http://schemas.microsoft.com/office/drawing/2014/main" id="{353B8CE3-9211-02C1-2D5E-4A977B17C1A7}"/>
               </a:ext>
             </a:extLst>
           </p:cNvPr>
@@ -10922,7 +10922,7 @@
           <p:cNvPr id="11" name="TextBox 10">
             <a:extLst>
               <a:ext uri="{FF2B5EF4-FFF2-40B4-BE49-F238E27FC236}">
-                <a16:creationId xmlns:a16="http://schemas.microsoft.com/office/drawing/2014/main" id="{8ED85064-C6D5-C868-B51B-F1EB02772626}"/>
+                <a16:creationId xmlns:a16="http://schemas.microsoft.com/office/drawing/2014/main" id="{4D2325BC-316E-7D91-483D-3A2BB2124129}"/>
               </a:ext>
             </a:extLst>
           </p:cNvPr>
@@ -10969,7 +10969,7 @@
           <p:cNvPr id="12" name="TextBox 11">
             <a:extLst>
               <a:ext uri="{FF2B5EF4-FFF2-40B4-BE49-F238E27FC236}">
-                <a16:creationId xmlns:a16="http://schemas.microsoft.com/office/drawing/2014/main" id="{24144263-EACD-41F2-B62A-A338AA328BAA}"/>
+                <a16:creationId xmlns:a16="http://schemas.microsoft.com/office/drawing/2014/main" id="{0531F871-01B6-DAF3-18C1-ABAF42762A47}"/>
               </a:ext>
             </a:extLst>
           </p:cNvPr>
@@ -11041,7 +11041,7 @@
           <p:cNvPr id="13" name="Rectangle: Rounded Corners 12">
             <a:extLst>
               <a:ext uri="{FF2B5EF4-FFF2-40B4-BE49-F238E27FC236}">
-                <a16:creationId xmlns:a16="http://schemas.microsoft.com/office/drawing/2014/main" id="{B7393FE2-7599-1351-70BC-04CF790AC1F9}"/>
+                <a16:creationId xmlns:a16="http://schemas.microsoft.com/office/drawing/2014/main" id="{1E889988-24BE-0870-8D52-5328A542C6F3}"/>
               </a:ext>
             </a:extLst>
           </p:cNvPr>
@@ -11095,7 +11095,7 @@
           <p:cNvPr id="14" name="TextBox 13">
             <a:extLst>
               <a:ext uri="{FF2B5EF4-FFF2-40B4-BE49-F238E27FC236}">
-                <a16:creationId xmlns:a16="http://schemas.microsoft.com/office/drawing/2014/main" id="{69EE754F-977C-0913-92A6-90DC3558D305}"/>
+                <a16:creationId xmlns:a16="http://schemas.microsoft.com/office/drawing/2014/main" id="{9877EEA8-51C3-F7FD-D82F-B4D64ED20BD6}"/>
               </a:ext>
             </a:extLst>
           </p:cNvPr>
@@ -11142,7 +11142,7 @@
           <p:cNvPr id="15" name="TextBox 14">
             <a:extLst>
               <a:ext uri="{FF2B5EF4-FFF2-40B4-BE49-F238E27FC236}">
-                <a16:creationId xmlns:a16="http://schemas.microsoft.com/office/drawing/2014/main" id="{18EE5C73-9E03-FCDE-6EE4-67F9D86ACFD4}"/>
+                <a16:creationId xmlns:a16="http://schemas.microsoft.com/office/drawing/2014/main" id="{1E4A710C-686F-43C7-8F0F-665D008F4218}"/>
               </a:ext>
             </a:extLst>
           </p:cNvPr>
@@ -11230,7 +11230,7 @@
     </p:spTree>
     <p:extLst>
       <p:ext uri="{BB962C8B-B14F-4D97-AF65-F5344CB8AC3E}">
-        <p14:creationId xmlns:p14="http://schemas.microsoft.com/office/powerpoint/2010/main" val="2670099941"/>
+        <p14:creationId xmlns:p14="http://schemas.microsoft.com/office/powerpoint/2010/main" val="2501673859"/>
       </p:ext>
     </p:extLst>
   </p:cSld>
@@ -11262,7 +11262,7 @@
           <p:cNvPr id="2" name="Rectangle 1">
             <a:extLst>
               <a:ext uri="{FF2B5EF4-FFF2-40B4-BE49-F238E27FC236}">
-                <a16:creationId xmlns:a16="http://schemas.microsoft.com/office/drawing/2014/main" id="{BF18A8B0-8C34-BDEB-71CF-451B80EE45C5}"/>
+                <a16:creationId xmlns:a16="http://schemas.microsoft.com/office/drawing/2014/main" id="{ECCCF9B2-9E5B-4C90-C6E0-11243D295089}"/>
               </a:ext>
             </a:extLst>
           </p:cNvPr>
@@ -11330,7 +11330,7 @@
           <p:cNvPr id="3" name="Rectangle 2">
             <a:extLst>
               <a:ext uri="{FF2B5EF4-FFF2-40B4-BE49-F238E27FC236}">
-                <a16:creationId xmlns:a16="http://schemas.microsoft.com/office/drawing/2014/main" id="{D6806119-5628-16E6-0318-EAB3D4E12914}"/>
+                <a16:creationId xmlns:a16="http://schemas.microsoft.com/office/drawing/2014/main" id="{4917099C-EA68-5886-4C06-56F18A2CF3B3}"/>
               </a:ext>
             </a:extLst>
           </p:cNvPr>
@@ -11398,7 +11398,7 @@
           <p:cNvPr id="4" name="TextBox 3">
             <a:extLst>
               <a:ext uri="{FF2B5EF4-FFF2-40B4-BE49-F238E27FC236}">
-                <a16:creationId xmlns:a16="http://schemas.microsoft.com/office/drawing/2014/main" id="{F441CF46-51E5-DB94-909E-3EE354EF34B5}"/>
+                <a16:creationId xmlns:a16="http://schemas.microsoft.com/office/drawing/2014/main" id="{05F60B43-FC17-447F-3EBF-230B729C03B5}"/>
               </a:ext>
             </a:extLst>
           </p:cNvPr>
@@ -11466,7 +11466,7 @@
           <p:cNvPr id="5" name="TextBox 4">
             <a:extLst>
               <a:ext uri="{FF2B5EF4-FFF2-40B4-BE49-F238E27FC236}">
-                <a16:creationId xmlns:a16="http://schemas.microsoft.com/office/drawing/2014/main" id="{CB0D2A34-1F46-1EDB-0B6A-AAA054293168}"/>
+                <a16:creationId xmlns:a16="http://schemas.microsoft.com/office/drawing/2014/main" id="{DB38E216-CFA4-8507-428A-B6F277304B91}"/>
               </a:ext>
             </a:extLst>
           </p:cNvPr>
@@ -11513,7 +11513,7 @@
           <p:cNvPr id="6" name="TextBox 5">
             <a:extLst>
               <a:ext uri="{FF2B5EF4-FFF2-40B4-BE49-F238E27FC236}">
-                <a16:creationId xmlns:a16="http://schemas.microsoft.com/office/drawing/2014/main" id="{90913C27-3EC4-F7F9-9288-1B2C0A7EB0DF}"/>
+                <a16:creationId xmlns:a16="http://schemas.microsoft.com/office/drawing/2014/main" id="{A7CB8EE2-95E4-0CAC-8218-1C83EBF0439F}"/>
               </a:ext>
             </a:extLst>
           </p:cNvPr>
@@ -11553,7 +11553,7 @@
           <p:cNvPr id="7" name="Rectangle: Rounded Corners 6">
             <a:extLst>
               <a:ext uri="{FF2B5EF4-FFF2-40B4-BE49-F238E27FC236}">
-                <a16:creationId xmlns:a16="http://schemas.microsoft.com/office/drawing/2014/main" id="{8F30B055-A503-34E5-38C8-ED795EE41AA9}"/>
+                <a16:creationId xmlns:a16="http://schemas.microsoft.com/office/drawing/2014/main" id="{7216E8E6-4885-9073-E302-EFDAB38C5557}"/>
               </a:ext>
             </a:extLst>
           </p:cNvPr>
@@ -11607,7 +11607,7 @@
           <p:cNvPr id="8" name="TextBox 7">
             <a:extLst>
               <a:ext uri="{FF2B5EF4-FFF2-40B4-BE49-F238E27FC236}">
-                <a16:creationId xmlns:a16="http://schemas.microsoft.com/office/drawing/2014/main" id="{61FC1D1C-D8A5-FFD8-D231-35DBFEE7D3C2}"/>
+                <a16:creationId xmlns:a16="http://schemas.microsoft.com/office/drawing/2014/main" id="{12C4DFAD-BF31-8852-9FB5-2B751F3C714B}"/>
               </a:ext>
             </a:extLst>
           </p:cNvPr>
@@ -11663,7 +11663,7 @@
           <p:cNvPr id="9" name="TextBox 8">
             <a:extLst>
               <a:ext uri="{FF2B5EF4-FFF2-40B4-BE49-F238E27FC236}">
-                <a16:creationId xmlns:a16="http://schemas.microsoft.com/office/drawing/2014/main" id="{0B9B29FA-6775-1F46-6B5D-B822BE955FF6}"/>
+                <a16:creationId xmlns:a16="http://schemas.microsoft.com/office/drawing/2014/main" id="{9E4E1015-D4A6-C9EF-7CB9-7CCB8CF112D1}"/>
               </a:ext>
             </a:extLst>
           </p:cNvPr>
@@ -11734,7 +11734,7 @@
           <p:cNvPr id="10" name="Rectangle: Rounded Corners 9">
             <a:extLst>
               <a:ext uri="{FF2B5EF4-FFF2-40B4-BE49-F238E27FC236}">
-                <a16:creationId xmlns:a16="http://schemas.microsoft.com/office/drawing/2014/main" id="{300FD58F-42F5-6C4B-8C00-C59F2105B244}"/>
+                <a16:creationId xmlns:a16="http://schemas.microsoft.com/office/drawing/2014/main" id="{4BF06D4C-A1E5-86DD-DF94-983C9B4B665B}"/>
               </a:ext>
             </a:extLst>
           </p:cNvPr>
@@ -11788,7 +11788,7 @@
           <p:cNvPr id="11" name="TextBox 10">
             <a:extLst>
               <a:ext uri="{FF2B5EF4-FFF2-40B4-BE49-F238E27FC236}">
-                <a16:creationId xmlns:a16="http://schemas.microsoft.com/office/drawing/2014/main" id="{1666BC15-A216-3868-DEE2-393547A0A9BC}"/>
+                <a16:creationId xmlns:a16="http://schemas.microsoft.com/office/drawing/2014/main" id="{7965F68D-1C3D-1114-270F-D31CB2DB876E}"/>
               </a:ext>
             </a:extLst>
           </p:cNvPr>
@@ -11844,7 +11844,7 @@
           <p:cNvPr id="12" name="TextBox 11">
             <a:extLst>
               <a:ext uri="{FF2B5EF4-FFF2-40B4-BE49-F238E27FC236}">
-                <a16:creationId xmlns:a16="http://schemas.microsoft.com/office/drawing/2014/main" id="{0EF3CFFF-F674-CDE0-0C51-7E4799BB59CA}"/>
+                <a16:creationId xmlns:a16="http://schemas.microsoft.com/office/drawing/2014/main" id="{CE13DB87-5B4A-1B9D-747B-97B9CD237051}"/>
               </a:ext>
             </a:extLst>
           </p:cNvPr>
@@ -11915,7 +11915,7 @@
           <p:cNvPr id="13" name="Rectangle: Rounded Corners 12">
             <a:extLst>
               <a:ext uri="{FF2B5EF4-FFF2-40B4-BE49-F238E27FC236}">
-                <a16:creationId xmlns:a16="http://schemas.microsoft.com/office/drawing/2014/main" id="{A6E683EC-E3A9-C5B7-0B3B-991CB7617030}"/>
+                <a16:creationId xmlns:a16="http://schemas.microsoft.com/office/drawing/2014/main" id="{849089F4-1DAB-2B1B-18B6-1F471C9B386D}"/>
               </a:ext>
             </a:extLst>
           </p:cNvPr>
@@ -11969,7 +11969,7 @@
           <p:cNvPr id="14" name="TextBox 13">
             <a:extLst>
               <a:ext uri="{FF2B5EF4-FFF2-40B4-BE49-F238E27FC236}">
-                <a16:creationId xmlns:a16="http://schemas.microsoft.com/office/drawing/2014/main" id="{FDD7BAA7-D1D7-F1D6-EF54-76D00C1C2F8F}"/>
+                <a16:creationId xmlns:a16="http://schemas.microsoft.com/office/drawing/2014/main" id="{2822FB20-19E6-12EF-504B-385964C1809B}"/>
               </a:ext>
             </a:extLst>
           </p:cNvPr>
@@ -12025,7 +12025,7 @@
           <p:cNvPr id="15" name="TextBox 14">
             <a:extLst>
               <a:ext uri="{FF2B5EF4-FFF2-40B4-BE49-F238E27FC236}">
-                <a16:creationId xmlns:a16="http://schemas.microsoft.com/office/drawing/2014/main" id="{3B2D748F-FB03-50C4-0756-95A3B299C849}"/>
+                <a16:creationId xmlns:a16="http://schemas.microsoft.com/office/drawing/2014/main" id="{7E04E41A-2A3C-332A-B05E-09107698D9AB}"/>
               </a:ext>
             </a:extLst>
           </p:cNvPr>
@@ -12114,7 +12114,7 @@
           <p:cNvPr id="16" name="Rectangle: Rounded Corners 15">
             <a:extLst>
               <a:ext uri="{FF2B5EF4-FFF2-40B4-BE49-F238E27FC236}">
-                <a16:creationId xmlns:a16="http://schemas.microsoft.com/office/drawing/2014/main" id="{AD8E354B-3EC6-1030-7904-697C6A29EE3D}"/>
+                <a16:creationId xmlns:a16="http://schemas.microsoft.com/office/drawing/2014/main" id="{ECED7740-6AEF-6C9D-8B63-760BE376AD7D}"/>
               </a:ext>
             </a:extLst>
           </p:cNvPr>
@@ -12168,7 +12168,7 @@
           <p:cNvPr id="17" name="TextBox 16">
             <a:extLst>
               <a:ext uri="{FF2B5EF4-FFF2-40B4-BE49-F238E27FC236}">
-                <a16:creationId xmlns:a16="http://schemas.microsoft.com/office/drawing/2014/main" id="{1CFBBF19-18CA-3E8C-1A41-B2F43BDEA8D2}"/>
+                <a16:creationId xmlns:a16="http://schemas.microsoft.com/office/drawing/2014/main" id="{B663E22B-20FC-B412-5966-86E15FD2A999}"/>
               </a:ext>
             </a:extLst>
           </p:cNvPr>
@@ -12224,7 +12224,7 @@
           <p:cNvPr id="18" name="TextBox 17">
             <a:extLst>
               <a:ext uri="{FF2B5EF4-FFF2-40B4-BE49-F238E27FC236}">
-                <a16:creationId xmlns:a16="http://schemas.microsoft.com/office/drawing/2014/main" id="{9D6D14A6-6488-2AF3-BE2B-E64C48C0BD6C}"/>
+                <a16:creationId xmlns:a16="http://schemas.microsoft.com/office/drawing/2014/main" id="{D19EFC27-08EE-DCA8-EA31-41998C5B34C7}"/>
               </a:ext>
             </a:extLst>
           </p:cNvPr>
@@ -12293,7 +12293,7 @@
     </p:spTree>
     <p:extLst>
       <p:ext uri="{BB962C8B-B14F-4D97-AF65-F5344CB8AC3E}">
-        <p14:creationId xmlns:p14="http://schemas.microsoft.com/office/powerpoint/2010/main" val="2251537511"/>
+        <p14:creationId xmlns:p14="http://schemas.microsoft.com/office/powerpoint/2010/main" val="1753512280"/>
       </p:ext>
     </p:extLst>
   </p:cSld>
@@ -12325,7 +12325,7 @@
           <p:cNvPr id="2" name="Rectangle 1">
             <a:extLst>
               <a:ext uri="{FF2B5EF4-FFF2-40B4-BE49-F238E27FC236}">
-                <a16:creationId xmlns:a16="http://schemas.microsoft.com/office/drawing/2014/main" id="{7FB92225-04E2-A190-32D8-42A45414BE2E}"/>
+                <a16:creationId xmlns:a16="http://schemas.microsoft.com/office/drawing/2014/main" id="{FAE6A7DD-3A3C-CA26-7727-8A8CE5FA2AFD}"/>
               </a:ext>
             </a:extLst>
           </p:cNvPr>
@@ -12393,7 +12393,7 @@
           <p:cNvPr id="3" name="Rectangle 2">
             <a:extLst>
               <a:ext uri="{FF2B5EF4-FFF2-40B4-BE49-F238E27FC236}">
-                <a16:creationId xmlns:a16="http://schemas.microsoft.com/office/drawing/2014/main" id="{E72018FD-B6B4-633A-AD68-2BF4A061C688}"/>
+                <a16:creationId xmlns:a16="http://schemas.microsoft.com/office/drawing/2014/main" id="{D4F6DEF0-25D1-C775-5B50-7BE0AE12F407}"/>
               </a:ext>
             </a:extLst>
           </p:cNvPr>
@@ -12461,7 +12461,7 @@
           <p:cNvPr id="4" name="TextBox 3">
             <a:extLst>
               <a:ext uri="{FF2B5EF4-FFF2-40B4-BE49-F238E27FC236}">
-                <a16:creationId xmlns:a16="http://schemas.microsoft.com/office/drawing/2014/main" id="{37142E46-41BE-8BE9-ABDF-CB71F5368AF8}"/>
+                <a16:creationId xmlns:a16="http://schemas.microsoft.com/office/drawing/2014/main" id="{0A35FE54-3AED-B4E7-CCB7-C9AAAC86E070}"/>
               </a:ext>
             </a:extLst>
           </p:cNvPr>
@@ -12529,7 +12529,7 @@
           <p:cNvPr id="5" name="TextBox 4">
             <a:extLst>
               <a:ext uri="{FF2B5EF4-FFF2-40B4-BE49-F238E27FC236}">
-                <a16:creationId xmlns:a16="http://schemas.microsoft.com/office/drawing/2014/main" id="{C33F1269-0440-5058-6704-0B38B7F23EBB}"/>
+                <a16:creationId xmlns:a16="http://schemas.microsoft.com/office/drawing/2014/main" id="{48EA24ED-0A70-1625-3196-A55F0ED2E065}"/>
               </a:ext>
             </a:extLst>
           </p:cNvPr>
@@ -12576,7 +12576,7 @@
           <p:cNvPr id="6" name="TextBox 5">
             <a:extLst>
               <a:ext uri="{FF2B5EF4-FFF2-40B4-BE49-F238E27FC236}">
-                <a16:creationId xmlns:a16="http://schemas.microsoft.com/office/drawing/2014/main" id="{83934541-19B9-183C-D1A5-E2C707A6AB26}"/>
+                <a16:creationId xmlns:a16="http://schemas.microsoft.com/office/drawing/2014/main" id="{1FB884B7-51B1-2251-46F1-2047EBFBDBD5}"/>
               </a:ext>
             </a:extLst>
           </p:cNvPr>
@@ -12616,7 +12616,7 @@
           <p:cNvPr id="7" name="Rectangle: Rounded Corners 6">
             <a:extLst>
               <a:ext uri="{FF2B5EF4-FFF2-40B4-BE49-F238E27FC236}">
-                <a16:creationId xmlns:a16="http://schemas.microsoft.com/office/drawing/2014/main" id="{E8795BB9-4FBB-CFF9-0FDD-E9065F348242}"/>
+                <a16:creationId xmlns:a16="http://schemas.microsoft.com/office/drawing/2014/main" id="{5E5F611A-3755-5063-E266-0DC3C698CA61}"/>
               </a:ext>
             </a:extLst>
           </p:cNvPr>
@@ -12670,7 +12670,7 @@
           <p:cNvPr id="8" name="TextBox 7">
             <a:extLst>
               <a:ext uri="{FF2B5EF4-FFF2-40B4-BE49-F238E27FC236}">
-                <a16:creationId xmlns:a16="http://schemas.microsoft.com/office/drawing/2014/main" id="{31FB6840-ECE5-B027-F3F3-3496842D4DBF}"/>
+                <a16:creationId xmlns:a16="http://schemas.microsoft.com/office/drawing/2014/main" id="{27A9045A-E69E-FC1F-7A57-AB34FFB5E4B1}"/>
               </a:ext>
             </a:extLst>
           </p:cNvPr>
@@ -12717,7 +12717,7 @@
           <p:cNvPr id="9" name="TextBox 8">
             <a:extLst>
               <a:ext uri="{FF2B5EF4-FFF2-40B4-BE49-F238E27FC236}">
-                <a16:creationId xmlns:a16="http://schemas.microsoft.com/office/drawing/2014/main" id="{FF718639-78E2-BCBB-2F5B-28D729D92166}"/>
+                <a16:creationId xmlns:a16="http://schemas.microsoft.com/office/drawing/2014/main" id="{30FF2A1C-8AC3-555D-3C81-C0B11A34BEB5}"/>
               </a:ext>
             </a:extLst>
           </p:cNvPr>
@@ -12844,7 +12844,7 @@
           <p:cNvPr id="10" name="Rectangle: Rounded Corners 9">
             <a:extLst>
               <a:ext uri="{FF2B5EF4-FFF2-40B4-BE49-F238E27FC236}">
-                <a16:creationId xmlns:a16="http://schemas.microsoft.com/office/drawing/2014/main" id="{CE482817-7E51-C33D-2320-2D96AD989174}"/>
+                <a16:creationId xmlns:a16="http://schemas.microsoft.com/office/drawing/2014/main" id="{38471160-663D-ED1F-AB5B-BAAC343BF586}"/>
               </a:ext>
             </a:extLst>
           </p:cNvPr>
@@ -12898,7 +12898,7 @@
           <p:cNvPr id="11" name="TextBox 10">
             <a:extLst>
               <a:ext uri="{FF2B5EF4-FFF2-40B4-BE49-F238E27FC236}">
-                <a16:creationId xmlns:a16="http://schemas.microsoft.com/office/drawing/2014/main" id="{D977BE5F-41BC-5428-C5C0-68B7D2A0A98D}"/>
+                <a16:creationId xmlns:a16="http://schemas.microsoft.com/office/drawing/2014/main" id="{0A89FBEA-539B-81E0-AA5A-8C8CE52FC6FB}"/>
               </a:ext>
             </a:extLst>
           </p:cNvPr>
@@ -12945,7 +12945,7 @@
           <p:cNvPr id="12" name="TextBox 11">
             <a:extLst>
               <a:ext uri="{FF2B5EF4-FFF2-40B4-BE49-F238E27FC236}">
-                <a16:creationId xmlns:a16="http://schemas.microsoft.com/office/drawing/2014/main" id="{E581ED40-77E2-4138-B80A-EDD50F803B72}"/>
+                <a16:creationId xmlns:a16="http://schemas.microsoft.com/office/drawing/2014/main" id="{CC281E21-43CC-A491-B7C2-B9168DEAF5B0}"/>
               </a:ext>
             </a:extLst>
           </p:cNvPr>
@@ -13034,7 +13034,7 @@
     </p:spTree>
     <p:extLst>
       <p:ext uri="{BB962C8B-B14F-4D97-AF65-F5344CB8AC3E}">
-        <p14:creationId xmlns:p14="http://schemas.microsoft.com/office/powerpoint/2010/main" val="3881958663"/>
+        <p14:creationId xmlns:p14="http://schemas.microsoft.com/office/powerpoint/2010/main" val="1905162716"/>
       </p:ext>
     </p:extLst>
   </p:cSld>
@@ -13066,7 +13066,7 @@
           <p:cNvPr id="2" name="Rectangle 1">
             <a:extLst>
               <a:ext uri="{FF2B5EF4-FFF2-40B4-BE49-F238E27FC236}">
-                <a16:creationId xmlns:a16="http://schemas.microsoft.com/office/drawing/2014/main" id="{C4CFCFA6-1BDC-AEDB-085A-C6CA32A31A6A}"/>
+                <a16:creationId xmlns:a16="http://schemas.microsoft.com/office/drawing/2014/main" id="{70731A61-278C-DEFE-6918-DD3CB56453F4}"/>
               </a:ext>
             </a:extLst>
           </p:cNvPr>
@@ -13134,7 +13134,7 @@
           <p:cNvPr id="3" name="Rectangle 2">
             <a:extLst>
               <a:ext uri="{FF2B5EF4-FFF2-40B4-BE49-F238E27FC236}">
-                <a16:creationId xmlns:a16="http://schemas.microsoft.com/office/drawing/2014/main" id="{C5308CC2-E243-9BD6-2AED-43209B04152D}"/>
+                <a16:creationId xmlns:a16="http://schemas.microsoft.com/office/drawing/2014/main" id="{0C256333-2AAF-16D4-0FC6-EB91DC1C0CCF}"/>
               </a:ext>
             </a:extLst>
           </p:cNvPr>
@@ -13202,7 +13202,7 @@
           <p:cNvPr id="4" name="TextBox 3">
             <a:extLst>
               <a:ext uri="{FF2B5EF4-FFF2-40B4-BE49-F238E27FC236}">
-                <a16:creationId xmlns:a16="http://schemas.microsoft.com/office/drawing/2014/main" id="{0102B691-C5AC-B46E-05FC-F16797E1CBE1}"/>
+                <a16:creationId xmlns:a16="http://schemas.microsoft.com/office/drawing/2014/main" id="{82CE01A4-CAC8-F935-C760-30DF9E4BD73F}"/>
               </a:ext>
             </a:extLst>
           </p:cNvPr>
@@ -13270,7 +13270,7 @@
           <p:cNvPr id="5" name="TextBox 4">
             <a:extLst>
               <a:ext uri="{FF2B5EF4-FFF2-40B4-BE49-F238E27FC236}">
-                <a16:creationId xmlns:a16="http://schemas.microsoft.com/office/drawing/2014/main" id="{6C8349A0-5976-35F7-FF5F-CA08CEDAD36B}"/>
+                <a16:creationId xmlns:a16="http://schemas.microsoft.com/office/drawing/2014/main" id="{E4746ED7-4127-039F-26DB-1BA34586BEC4}"/>
               </a:ext>
             </a:extLst>
           </p:cNvPr>
@@ -13320,7 +13320,7 @@
           <p:cNvPr id="6" name="TextBox 5">
             <a:extLst>
               <a:ext uri="{FF2B5EF4-FFF2-40B4-BE49-F238E27FC236}">
-                <a16:creationId xmlns:a16="http://schemas.microsoft.com/office/drawing/2014/main" id="{E8BDA30B-DFA3-EFA7-7F35-D4AF3EE451D4}"/>
+                <a16:creationId xmlns:a16="http://schemas.microsoft.com/office/drawing/2014/main" id="{C75AB2A4-1287-A90E-B318-AFF1D0DD1FDD}"/>
               </a:ext>
             </a:extLst>
           </p:cNvPr>
@@ -13360,7 +13360,7 @@
           <p:cNvPr id="7" name="Rectangle: Rounded Corners 6">
             <a:extLst>
               <a:ext uri="{FF2B5EF4-FFF2-40B4-BE49-F238E27FC236}">
-                <a16:creationId xmlns:a16="http://schemas.microsoft.com/office/drawing/2014/main" id="{C0C844B6-BE9E-58EB-6984-8BAFBD32442B}"/>
+                <a16:creationId xmlns:a16="http://schemas.microsoft.com/office/drawing/2014/main" id="{A876CC31-9D21-7CBC-C677-E388878D2A21}"/>
               </a:ext>
             </a:extLst>
           </p:cNvPr>
@@ -13414,7 +13414,7 @@
           <p:cNvPr id="8" name="TextBox 7">
             <a:extLst>
               <a:ext uri="{FF2B5EF4-FFF2-40B4-BE49-F238E27FC236}">
-                <a16:creationId xmlns:a16="http://schemas.microsoft.com/office/drawing/2014/main" id="{CC2BD739-82A9-29DC-4192-9CCEC4925C68}"/>
+                <a16:creationId xmlns:a16="http://schemas.microsoft.com/office/drawing/2014/main" id="{F35C4C92-FFD4-D4F7-ED44-03A42E180191}"/>
               </a:ext>
             </a:extLst>
           </p:cNvPr>
@@ -13461,7 +13461,7 @@
           <p:cNvPr id="9" name="TextBox 8">
             <a:extLst>
               <a:ext uri="{FF2B5EF4-FFF2-40B4-BE49-F238E27FC236}">
-                <a16:creationId xmlns:a16="http://schemas.microsoft.com/office/drawing/2014/main" id="{96D1193D-F2A1-D783-52E1-FED411DA523B}"/>
+                <a16:creationId xmlns:a16="http://schemas.microsoft.com/office/drawing/2014/main" id="{3383A05B-12B4-E9B9-217A-13B24D284630}"/>
               </a:ext>
             </a:extLst>
           </p:cNvPr>
@@ -13514,7 +13514,7 @@
           <p:cNvPr id="10" name="Rectangle: Rounded Corners 9">
             <a:extLst>
               <a:ext uri="{FF2B5EF4-FFF2-40B4-BE49-F238E27FC236}">
-                <a16:creationId xmlns:a16="http://schemas.microsoft.com/office/drawing/2014/main" id="{9C96AFE0-BEC3-E847-3D3D-3757EFC766A2}"/>
+                <a16:creationId xmlns:a16="http://schemas.microsoft.com/office/drawing/2014/main" id="{22319DE5-1E71-237F-BCCA-CA2675C574AA}"/>
               </a:ext>
             </a:extLst>
           </p:cNvPr>
@@ -13568,7 +13568,7 @@
           <p:cNvPr id="11" name="TextBox 10">
             <a:extLst>
               <a:ext uri="{FF2B5EF4-FFF2-40B4-BE49-F238E27FC236}">
-                <a16:creationId xmlns:a16="http://schemas.microsoft.com/office/drawing/2014/main" id="{3B9C7D1C-DDC3-F03C-C36B-2338501B922F}"/>
+                <a16:creationId xmlns:a16="http://schemas.microsoft.com/office/drawing/2014/main" id="{48CE5F8C-17A9-9FC1-C32A-6D601A66AE5B}"/>
               </a:ext>
             </a:extLst>
           </p:cNvPr>
@@ -13615,7 +13615,7 @@
           <p:cNvPr id="12" name="TextBox 11">
             <a:extLst>
               <a:ext uri="{FF2B5EF4-FFF2-40B4-BE49-F238E27FC236}">
-                <a16:creationId xmlns:a16="http://schemas.microsoft.com/office/drawing/2014/main" id="{45D2E644-16F8-F907-DE85-59286C174677}"/>
+                <a16:creationId xmlns:a16="http://schemas.microsoft.com/office/drawing/2014/main" id="{D64E54A6-9977-DFA7-9686-76AE10FA8BEA}"/>
               </a:ext>
             </a:extLst>
           </p:cNvPr>
@@ -13668,7 +13668,7 @@
           <p:cNvPr id="13" name="Rectangle: Rounded Corners 12">
             <a:extLst>
               <a:ext uri="{FF2B5EF4-FFF2-40B4-BE49-F238E27FC236}">
-                <a16:creationId xmlns:a16="http://schemas.microsoft.com/office/drawing/2014/main" id="{8FAD82E7-0EEC-F4DA-A042-D430FEC40718}"/>
+                <a16:creationId xmlns:a16="http://schemas.microsoft.com/office/drawing/2014/main" id="{CB969BBE-A263-6132-459C-84C21BC4E210}"/>
               </a:ext>
             </a:extLst>
           </p:cNvPr>
@@ -13722,7 +13722,7 @@
           <p:cNvPr id="14" name="TextBox 13">
             <a:extLst>
               <a:ext uri="{FF2B5EF4-FFF2-40B4-BE49-F238E27FC236}">
-                <a16:creationId xmlns:a16="http://schemas.microsoft.com/office/drawing/2014/main" id="{0D670843-0507-4750-D250-39710727578F}"/>
+                <a16:creationId xmlns:a16="http://schemas.microsoft.com/office/drawing/2014/main" id="{D30B2BEE-3958-B28A-ABE2-8C7556BF238B}"/>
               </a:ext>
             </a:extLst>
           </p:cNvPr>
@@ -13772,7 +13772,7 @@
           <p:cNvPr id="15" name="TextBox 14">
             <a:extLst>
               <a:ext uri="{FF2B5EF4-FFF2-40B4-BE49-F238E27FC236}">
-                <a16:creationId xmlns:a16="http://schemas.microsoft.com/office/drawing/2014/main" id="{EB8AE801-3BAD-8AEE-48C8-C7642C592C30}"/>
+                <a16:creationId xmlns:a16="http://schemas.microsoft.com/office/drawing/2014/main" id="{C092F5AF-8382-2AFA-3593-036415B80BAE}"/>
               </a:ext>
             </a:extLst>
           </p:cNvPr>
@@ -13823,7 +13823,7 @@
     </p:spTree>
     <p:extLst>
       <p:ext uri="{BB962C8B-B14F-4D97-AF65-F5344CB8AC3E}">
-        <p14:creationId xmlns:p14="http://schemas.microsoft.com/office/powerpoint/2010/main" val="3403912455"/>
+        <p14:creationId xmlns:p14="http://schemas.microsoft.com/office/powerpoint/2010/main" val="2363002382"/>
       </p:ext>
     </p:extLst>
   </p:cSld>
@@ -13855,7 +13855,7 @@
           <p:cNvPr id="2" name="Rectangle 1">
             <a:extLst>
               <a:ext uri="{FF2B5EF4-FFF2-40B4-BE49-F238E27FC236}">
-                <a16:creationId xmlns:a16="http://schemas.microsoft.com/office/drawing/2014/main" id="{D2859569-777D-7CF0-1770-7E1B6A9D3F13}"/>
+                <a16:creationId xmlns:a16="http://schemas.microsoft.com/office/drawing/2014/main" id="{C48DE051-923B-A101-FF62-D66062F20C03}"/>
               </a:ext>
             </a:extLst>
           </p:cNvPr>
@@ -13923,7 +13923,7 @@
           <p:cNvPr id="3" name="Rectangle 2">
             <a:extLst>
               <a:ext uri="{FF2B5EF4-FFF2-40B4-BE49-F238E27FC236}">
-                <a16:creationId xmlns:a16="http://schemas.microsoft.com/office/drawing/2014/main" id="{BE15FB87-0347-A796-D958-939A79E852BD}"/>
+                <a16:creationId xmlns:a16="http://schemas.microsoft.com/office/drawing/2014/main" id="{590F94E2-53D9-0161-1D43-9FB49412DE71}"/>
               </a:ext>
             </a:extLst>
           </p:cNvPr>
@@ -13991,7 +13991,7 @@
           <p:cNvPr id="4" name="TextBox 3">
             <a:extLst>
               <a:ext uri="{FF2B5EF4-FFF2-40B4-BE49-F238E27FC236}">
-                <a16:creationId xmlns:a16="http://schemas.microsoft.com/office/drawing/2014/main" id="{6F6E7D29-2B3D-21D8-5095-97AB9E0F275E}"/>
+                <a16:creationId xmlns:a16="http://schemas.microsoft.com/office/drawing/2014/main" id="{79105F8E-EFE2-B382-AEE2-E992CF49B526}"/>
               </a:ext>
             </a:extLst>
           </p:cNvPr>
@@ -14059,7 +14059,7 @@
           <p:cNvPr id="5" name="TextBox 4">
             <a:extLst>
               <a:ext uri="{FF2B5EF4-FFF2-40B4-BE49-F238E27FC236}">
-                <a16:creationId xmlns:a16="http://schemas.microsoft.com/office/drawing/2014/main" id="{678D443A-CE0F-97DC-97A9-339119762BB7}"/>
+                <a16:creationId xmlns:a16="http://schemas.microsoft.com/office/drawing/2014/main" id="{61937E48-2A3E-5DB9-CDCB-DFC9588FB877}"/>
               </a:ext>
             </a:extLst>
           </p:cNvPr>
@@ -14106,7 +14106,7 @@
           <p:cNvPr id="6" name="TextBox 5">
             <a:extLst>
               <a:ext uri="{FF2B5EF4-FFF2-40B4-BE49-F238E27FC236}">
-                <a16:creationId xmlns:a16="http://schemas.microsoft.com/office/drawing/2014/main" id="{C6813DB9-796B-A095-3A13-BAEEBCD12C7E}"/>
+                <a16:creationId xmlns:a16="http://schemas.microsoft.com/office/drawing/2014/main" id="{49AB129B-E10B-BB19-AF93-E3F85964E1A8}"/>
               </a:ext>
             </a:extLst>
           </p:cNvPr>
@@ -14146,7 +14146,7 @@
           <p:cNvPr id="7" name="Rectangle: Rounded Corners 6">
             <a:extLst>
               <a:ext uri="{FF2B5EF4-FFF2-40B4-BE49-F238E27FC236}">
-                <a16:creationId xmlns:a16="http://schemas.microsoft.com/office/drawing/2014/main" id="{952B41B3-44D5-6C6F-ED00-8328B28E7543}"/>
+                <a16:creationId xmlns:a16="http://schemas.microsoft.com/office/drawing/2014/main" id="{A918F413-142B-D363-3E87-CD904FA582B6}"/>
               </a:ext>
             </a:extLst>
           </p:cNvPr>
@@ -14200,7 +14200,7 @@
           <p:cNvPr id="8" name="TextBox 7">
             <a:extLst>
               <a:ext uri="{FF2B5EF4-FFF2-40B4-BE49-F238E27FC236}">
-                <a16:creationId xmlns:a16="http://schemas.microsoft.com/office/drawing/2014/main" id="{F88CC011-0AFB-8595-F7D5-43719A7F1040}"/>
+                <a16:creationId xmlns:a16="http://schemas.microsoft.com/office/drawing/2014/main" id="{F8CC62FA-96AA-5FE5-8B78-681159CDA6B1}"/>
               </a:ext>
             </a:extLst>
           </p:cNvPr>
@@ -14250,7 +14250,7 @@
           <p:cNvPr id="9" name="TextBox 8">
             <a:extLst>
               <a:ext uri="{FF2B5EF4-FFF2-40B4-BE49-F238E27FC236}">
-                <a16:creationId xmlns:a16="http://schemas.microsoft.com/office/drawing/2014/main" id="{88885BBE-A915-846C-85C6-1C08C18C6039}"/>
+                <a16:creationId xmlns:a16="http://schemas.microsoft.com/office/drawing/2014/main" id="{7A1ABA4B-EC8D-A3D1-CB0D-8D3B0F7B9668}"/>
               </a:ext>
             </a:extLst>
           </p:cNvPr>
@@ -14339,7 +14339,7 @@
           <p:cNvPr id="10" name="Rectangle: Rounded Corners 9">
             <a:extLst>
               <a:ext uri="{FF2B5EF4-FFF2-40B4-BE49-F238E27FC236}">
-                <a16:creationId xmlns:a16="http://schemas.microsoft.com/office/drawing/2014/main" id="{CE396661-3648-BBDC-1C2F-A67E53477D24}"/>
+                <a16:creationId xmlns:a16="http://schemas.microsoft.com/office/drawing/2014/main" id="{98DDD303-0118-F688-3B27-7A24A38F740B}"/>
               </a:ext>
             </a:extLst>
           </p:cNvPr>
@@ -14393,7 +14393,7 @@
           <p:cNvPr id="11" name="TextBox 10">
             <a:extLst>
               <a:ext uri="{FF2B5EF4-FFF2-40B4-BE49-F238E27FC236}">
-                <a16:creationId xmlns:a16="http://schemas.microsoft.com/office/drawing/2014/main" id="{43AEDEB3-6E2D-C37D-2CE7-E1FD23D70672}"/>
+                <a16:creationId xmlns:a16="http://schemas.microsoft.com/office/drawing/2014/main" id="{8F242319-80A5-193E-AF8B-17DD93A17C12}"/>
               </a:ext>
             </a:extLst>
           </p:cNvPr>
@@ -14440,7 +14440,7 @@
           <p:cNvPr id="12" name="TextBox 11">
             <a:extLst>
               <a:ext uri="{FF2B5EF4-FFF2-40B4-BE49-F238E27FC236}">
-                <a16:creationId xmlns:a16="http://schemas.microsoft.com/office/drawing/2014/main" id="{B146B3C8-3F2D-996B-6C65-1D4D77269502}"/>
+                <a16:creationId xmlns:a16="http://schemas.microsoft.com/office/drawing/2014/main" id="{0BFF9E34-2909-17BD-C45B-9006131B383E}"/>
               </a:ext>
             </a:extLst>
           </p:cNvPr>
@@ -14547,7 +14547,7 @@
           <p:cNvPr id="13" name="Rectangle: Rounded Corners 12">
             <a:extLst>
               <a:ext uri="{FF2B5EF4-FFF2-40B4-BE49-F238E27FC236}">
-                <a16:creationId xmlns:a16="http://schemas.microsoft.com/office/drawing/2014/main" id="{4BB4881A-AFCA-F41F-5377-733FD4B207B8}"/>
+                <a16:creationId xmlns:a16="http://schemas.microsoft.com/office/drawing/2014/main" id="{13B75BE3-96C2-0C30-38C3-5B1967E76C66}"/>
               </a:ext>
             </a:extLst>
           </p:cNvPr>
@@ -14601,7 +14601,7 @@
           <p:cNvPr id="14" name="TextBox 13">
             <a:extLst>
               <a:ext uri="{FF2B5EF4-FFF2-40B4-BE49-F238E27FC236}">
-                <a16:creationId xmlns:a16="http://schemas.microsoft.com/office/drawing/2014/main" id="{F21DF50D-7D9A-B396-3C7B-10CFBAA9359E}"/>
+                <a16:creationId xmlns:a16="http://schemas.microsoft.com/office/drawing/2014/main" id="{EC559001-E026-AB26-313F-6C2A93084609}"/>
               </a:ext>
             </a:extLst>
           </p:cNvPr>
@@ -14648,7 +14648,7 @@
           <p:cNvPr id="15" name="TextBox 14">
             <a:extLst>
               <a:ext uri="{FF2B5EF4-FFF2-40B4-BE49-F238E27FC236}">
-                <a16:creationId xmlns:a16="http://schemas.microsoft.com/office/drawing/2014/main" id="{749EE70B-D21B-A803-7CD1-8707821FC30C}"/>
+                <a16:creationId xmlns:a16="http://schemas.microsoft.com/office/drawing/2014/main" id="{1EBF64DE-2549-04FB-FE33-E301FB9D41E9}"/>
               </a:ext>
             </a:extLst>
           </p:cNvPr>
@@ -14717,7 +14717,7 @@
     </p:spTree>
     <p:extLst>
       <p:ext uri="{BB962C8B-B14F-4D97-AF65-F5344CB8AC3E}">
-        <p14:creationId xmlns:p14="http://schemas.microsoft.com/office/powerpoint/2010/main" val="419005747"/>
+        <p14:creationId xmlns:p14="http://schemas.microsoft.com/office/powerpoint/2010/main" val="1204520773"/>
       </p:ext>
     </p:extLst>
   </p:cSld>

</xml_diff>